<commit_message>
React 기초 ppt 수정
</commit_message>
<xml_diff>
--- a/material/[SeSAC_YDP_6] 22_React_소개.pptx
+++ b/material/[SeSAC_YDP_6] 22_React_소개.pptx
@@ -226,7 +226,7 @@
           <a:p>
             <a:fld id="{2EF3F159-7250-4DD4-91C2-13B35D56E1AF}" type="datetimeFigureOut">
               <a:rPr lang="ko-KR" altLang="en-US" smtClean="0"/>
-              <a:t>2024-07-11</a:t>
+              <a:t>2024-07-18</a:t>
             </a:fld>
             <a:endParaRPr lang="ko-KR" altLang="en-US"/>
           </a:p>
@@ -621,7 +621,69 @@
           <a:bodyPr/>
           <a:lstStyle/>
           <a:p>
-            <a:endParaRPr lang="ko-KR" altLang="en-US" dirty="0"/>
+            <a:r>
+              <a:rPr lang="ko-KR" altLang="en-US" dirty="0"/>
+              <a:t>블록</a:t>
+            </a:r>
+            <a:r>
+              <a:rPr lang="en-US" altLang="ko-KR" dirty="0"/>
+              <a:t>, </a:t>
+            </a:r>
+            <a:r>
+              <a:rPr lang="ko-KR" altLang="en-US" dirty="0"/>
+              <a:t>레고에 비유</a:t>
+            </a:r>
+            <a:r>
+              <a:rPr lang="en-US" altLang="ko-KR" dirty="0"/>
+              <a:t>.</a:t>
+            </a:r>
+          </a:p>
+          <a:p>
+            <a:endParaRPr lang="en-US" altLang="ko-KR" dirty="0"/>
+          </a:p>
+          <a:p>
+            <a:r>
+              <a:rPr lang="ko-KR" altLang="en-US" dirty="0"/>
+              <a:t>애플리케이션을 독립적인 재사용 가능한 컴포넌트 단위로 나누어 개발하는 방식</a:t>
+            </a:r>
+            <a:r>
+              <a:rPr lang="en-US" altLang="ko-KR" dirty="0"/>
+              <a:t>.</a:t>
+            </a:r>
+          </a:p>
+          <a:p>
+            <a:r>
+              <a:rPr lang="en-US" altLang="ko-KR" dirty="0"/>
+              <a:t>React</a:t>
+            </a:r>
+            <a:r>
+              <a:rPr lang="ko-KR" altLang="en-US" dirty="0"/>
+              <a:t>의 가장 큰 특징</a:t>
+            </a:r>
+            <a:r>
+              <a:rPr lang="en-US" altLang="ko-KR" dirty="0"/>
+              <a:t>.</a:t>
+            </a:r>
+          </a:p>
+          <a:p>
+            <a:r>
+              <a:rPr lang="ko-KR" altLang="en-US" dirty="0"/>
+              <a:t>대규모 애플리케이션을 체계적으로 관리하고 유지보수하기 쉽게 </a:t>
+            </a:r>
+            <a:r>
+              <a:rPr lang="ko-KR" altLang="en-US" dirty="0" err="1"/>
+              <a:t>만듬</a:t>
+            </a:r>
+            <a:r>
+              <a:rPr lang="en-US" altLang="ko-KR" dirty="0"/>
+              <a:t>.</a:t>
+            </a:r>
+          </a:p>
+          <a:p>
+            <a:endParaRPr lang="en-US" altLang="ko-KR" dirty="0"/>
+          </a:p>
+          <a:p>
+            <a:endParaRPr lang="en-US" altLang="ko-KR" dirty="0"/>
           </a:p>
         </p:txBody>
       </p:sp>
@@ -632,7 +694,7 @@
             <a:spLocks noGrp="1"/>
           </p:cNvSpPr>
           <p:nvPr>
-            <p:ph type="sldNum" sz="quarter" idx="10"/>
+            <p:ph type="sldNum" sz="quarter" idx="5"/>
           </p:nvPr>
         </p:nvSpPr>
         <p:spPr/>
@@ -642,7 +704,7 @@
           <a:p>
             <a:fld id="{C09E5BFC-1559-42F1-8940-AB342D56BF02}" type="slidenum">
               <a:rPr lang="ko-KR" altLang="en-US" smtClean="0"/>
-              <a:t>14</a:t>
+              <a:t>13</a:t>
             </a:fld>
             <a:endParaRPr lang="ko-KR" altLang="en-US"/>
           </a:p>
@@ -651,7 +713,7 @@
     </p:spTree>
     <p:extLst>
       <p:ext uri="{BB962C8B-B14F-4D97-AF65-F5344CB8AC3E}">
-        <p14:creationId xmlns:p14="http://schemas.microsoft.com/office/powerpoint/2010/main" val="1054828888"/>
+        <p14:creationId xmlns:p14="http://schemas.microsoft.com/office/powerpoint/2010/main" val="886286312"/>
       </p:ext>
     </p:extLst>
   </p:cSld>
@@ -705,6 +767,16 @@
           <a:bodyPr/>
           <a:lstStyle/>
           <a:p>
+            <a:r>
+              <a:rPr lang="ko-KR" altLang="en-US" dirty="0"/>
+              <a:t>동일한 컴포넌트를 여러 곳에서 재사용할 수 있어 코드 중복을 줄이고 일관성을 유지할 수 있다</a:t>
+            </a:r>
+            <a:r>
+              <a:rPr lang="en-US" altLang="ko-KR" dirty="0"/>
+              <a:t>.</a:t>
+            </a:r>
+          </a:p>
+          <a:p>
             <a:endParaRPr lang="ko-KR" altLang="en-US" dirty="0"/>
           </a:p>
         </p:txBody>
@@ -726,7 +798,7 @@
           <a:p>
             <a:fld id="{C09E5BFC-1559-42F1-8940-AB342D56BF02}" type="slidenum">
               <a:rPr lang="ko-KR" altLang="en-US" smtClean="0"/>
-              <a:t>18</a:t>
+              <a:t>14</a:t>
             </a:fld>
             <a:endParaRPr lang="ko-KR" altLang="en-US"/>
           </a:p>
@@ -735,7 +807,7 @@
     </p:spTree>
     <p:extLst>
       <p:ext uri="{BB962C8B-B14F-4D97-AF65-F5344CB8AC3E}">
-        <p14:creationId xmlns:p14="http://schemas.microsoft.com/office/powerpoint/2010/main" val="2852263773"/>
+        <p14:creationId xmlns:p14="http://schemas.microsoft.com/office/powerpoint/2010/main" val="1054828888"/>
       </p:ext>
     </p:extLst>
   </p:cSld>
@@ -789,6 +861,86 @@
           <a:bodyPr/>
           <a:lstStyle/>
           <a:p>
+            <a:r>
+              <a:rPr lang="ko-KR" altLang="en-US" dirty="0"/>
+              <a:t>컴포넌트는 부모</a:t>
+            </a:r>
+            <a:r>
+              <a:rPr lang="en-US" altLang="ko-KR" dirty="0"/>
+              <a:t>-</a:t>
+            </a:r>
+            <a:r>
+              <a:rPr lang="ko-KR" altLang="en-US" dirty="0"/>
+              <a:t>자식 관계를 통해 계층 구조를 형성</a:t>
+            </a:r>
+            <a:r>
+              <a:rPr lang="en-US" altLang="ko-KR" dirty="0"/>
+              <a:t>.</a:t>
+            </a:r>
+          </a:p>
+          <a:p>
+            <a:r>
+              <a:rPr lang="ko-KR" altLang="en-US" dirty="0"/>
+              <a:t>상위 컴포넌트는 하위 컴포넌트를 포함하고</a:t>
+            </a:r>
+            <a:r>
+              <a:rPr lang="en-US" altLang="ko-KR" dirty="0"/>
+              <a:t>, </a:t>
+            </a:r>
+            <a:r>
+              <a:rPr lang="ko-KR" altLang="en-US" dirty="0"/>
+              <a:t>데이터와 상태를 전달합니다</a:t>
+            </a:r>
+            <a:r>
+              <a:rPr lang="en-US" altLang="ko-KR" dirty="0"/>
+              <a:t>.</a:t>
+            </a:r>
+          </a:p>
+          <a:p>
+            <a:endParaRPr lang="en-US" altLang="ko-KR" dirty="0"/>
+          </a:p>
+          <a:p>
+            <a:r>
+              <a:rPr lang="ko-KR" altLang="en-US" dirty="0"/>
+              <a:t>여러 개의 작은 컴포넌트를 하나의 최상위 컴포넌트 안에 결합하여 전체 애플리케이션의 구조를 구성하는 것을 의미</a:t>
+            </a:r>
+            <a:r>
+              <a:rPr lang="en-US" altLang="ko-KR" dirty="0"/>
+              <a:t>.</a:t>
+            </a:r>
+          </a:p>
+          <a:p>
+            <a:endParaRPr lang="en-US" altLang="ko-KR" dirty="0"/>
+          </a:p>
+          <a:p>
+            <a:r>
+              <a:rPr lang="en-US" altLang="ko-KR" dirty="0"/>
+              <a:t>Root Component</a:t>
+            </a:r>
+            <a:r>
+              <a:rPr lang="ko-KR" altLang="en-US" dirty="0"/>
+              <a:t>는 애플리케이션의 진입점이 되며</a:t>
+            </a:r>
+            <a:r>
+              <a:rPr lang="en-US" altLang="ko-KR" dirty="0"/>
+              <a:t>, </a:t>
+            </a:r>
+            <a:r>
+              <a:rPr lang="ko-KR" altLang="en-US" dirty="0"/>
+              <a:t>이 컴포넌트 안에서 하위 컴포넌트들이 중첩되고 조합되어 최종 </a:t>
+            </a:r>
+            <a:r>
+              <a:rPr lang="en-US" altLang="ko-KR" dirty="0"/>
+              <a:t>UI</a:t>
+            </a:r>
+            <a:r>
+              <a:rPr lang="ko-KR" altLang="en-US" dirty="0"/>
+              <a:t>를 형성한다</a:t>
+            </a:r>
+            <a:r>
+              <a:rPr lang="en-US" altLang="ko-KR" dirty="0"/>
+              <a:t>.</a:t>
+            </a:r>
             <a:endParaRPr lang="ko-KR" altLang="en-US" dirty="0"/>
           </a:p>
         </p:txBody>
@@ -800,7 +952,7 @@
             <a:spLocks noGrp="1"/>
           </p:cNvSpPr>
           <p:nvPr>
-            <p:ph type="sldNum" sz="quarter" idx="10"/>
+            <p:ph type="sldNum" sz="quarter" idx="5"/>
           </p:nvPr>
         </p:nvSpPr>
         <p:spPr/>
@@ -810,7 +962,7 @@
           <a:p>
             <a:fld id="{C09E5BFC-1559-42F1-8940-AB342D56BF02}" type="slidenum">
               <a:rPr lang="ko-KR" altLang="en-US" smtClean="0"/>
-              <a:t>19</a:t>
+              <a:t>15</a:t>
             </a:fld>
             <a:endParaRPr lang="ko-KR" altLang="en-US"/>
           </a:p>
@@ -819,7 +971,7 @@
     </p:spTree>
     <p:extLst>
       <p:ext uri="{BB962C8B-B14F-4D97-AF65-F5344CB8AC3E}">
-        <p14:creationId xmlns:p14="http://schemas.microsoft.com/office/powerpoint/2010/main" val="3247079256"/>
+        <p14:creationId xmlns:p14="http://schemas.microsoft.com/office/powerpoint/2010/main" val="1998554671"/>
       </p:ext>
     </p:extLst>
   </p:cSld>
@@ -873,7 +1025,509 @@
           <a:bodyPr/>
           <a:lstStyle/>
           <a:p>
-            <a:endParaRPr lang="ko-KR" altLang="en-US" dirty="0"/>
+            <a:r>
+              <a:rPr lang="ko-KR" altLang="en-US" dirty="0"/>
+              <a:t>성능 최적화</a:t>
+            </a:r>
+            <a:r>
+              <a:rPr lang="en-US" altLang="ko-KR" dirty="0"/>
+              <a:t>, UI </a:t>
+            </a:r>
+            <a:r>
+              <a:rPr lang="ko-KR" altLang="en-US" dirty="0"/>
+              <a:t>업데이트의 효율성을 높이는 데 중요한 역할을 함</a:t>
+            </a:r>
+            <a:r>
+              <a:rPr lang="en-US" altLang="ko-KR" dirty="0"/>
+              <a:t>.</a:t>
+            </a:r>
+          </a:p>
+          <a:p>
+            <a:r>
+              <a:rPr lang="en-US" altLang="ko-KR" dirty="0"/>
+              <a:t>Virtual DOM</a:t>
+            </a:r>
+            <a:r>
+              <a:rPr lang="ko-KR" altLang="en-US" dirty="0"/>
+              <a:t>은 실제 </a:t>
+            </a:r>
+            <a:r>
+              <a:rPr lang="en-US" altLang="ko-KR" dirty="0"/>
+              <a:t>DOM</a:t>
+            </a:r>
+            <a:r>
+              <a:rPr lang="ko-KR" altLang="en-US" dirty="0"/>
+              <a:t>과 동일한 구조를 가지지만 메모리에 존재하며</a:t>
+            </a:r>
+            <a:r>
+              <a:rPr lang="en-US" altLang="ko-KR" dirty="0"/>
+              <a:t>, React </a:t>
+            </a:r>
+            <a:r>
+              <a:rPr lang="ko-KR" altLang="en-US" dirty="0"/>
+              <a:t>엔진이 관리하는 가상의 표현임</a:t>
+            </a:r>
+            <a:r>
+              <a:rPr lang="en-US" altLang="ko-KR" dirty="0"/>
+              <a:t>.</a:t>
+            </a:r>
+          </a:p>
+          <a:p>
+            <a:endParaRPr lang="en-US" altLang="ko-KR" dirty="0"/>
+          </a:p>
+          <a:p>
+            <a:pPr marL="0" indent="0">
+              <a:buFont typeface="Arial" panose="020B0604020202020204" pitchFamily="34" charset="0"/>
+              <a:buNone/>
+            </a:pPr>
+            <a:r>
+              <a:rPr lang="en-US" altLang="ko-KR" dirty="0"/>
+              <a:t>**</a:t>
+            </a:r>
+            <a:r>
+              <a:rPr lang="ko-KR" altLang="en-US" dirty="0"/>
+              <a:t> 동작 원리</a:t>
+            </a:r>
+            <a:endParaRPr lang="en-US" altLang="ko-KR" dirty="0"/>
+          </a:p>
+          <a:p>
+            <a:pPr marL="228600" indent="-228600">
+              <a:buFont typeface="Arial" panose="020B0604020202020204" pitchFamily="34" charset="0"/>
+              <a:buAutoNum type="arabicPeriod"/>
+            </a:pPr>
+            <a:r>
+              <a:rPr lang="ko-KR" altLang="en-US" dirty="0"/>
+              <a:t>가상 </a:t>
+            </a:r>
+            <a:r>
+              <a:rPr lang="en-US" altLang="ko-KR" dirty="0"/>
+              <a:t>DOM </a:t>
+            </a:r>
+            <a:r>
+              <a:rPr lang="ko-KR" altLang="en-US" dirty="0"/>
+              <a:t>구축</a:t>
+            </a:r>
+            <a:endParaRPr lang="en-US" altLang="ko-KR" dirty="0"/>
+          </a:p>
+          <a:p>
+            <a:pPr marL="171450" indent="-171450">
+              <a:buFont typeface="Wingdings" panose="05000000000000000000" pitchFamily="2" charset="2"/>
+              <a:buChar char="n"/>
+            </a:pPr>
+            <a:r>
+              <a:rPr lang="en-US" altLang="ko-KR" dirty="0"/>
+              <a:t>React </a:t>
+            </a:r>
+            <a:r>
+              <a:rPr lang="ko-KR" altLang="en-US" dirty="0"/>
+              <a:t>애플리케이션이 렌더링 될 때</a:t>
+            </a:r>
+            <a:r>
+              <a:rPr lang="en-US" altLang="ko-KR" dirty="0"/>
+              <a:t>, </a:t>
+            </a:r>
+            <a:r>
+              <a:rPr lang="ko-KR" altLang="en-US" dirty="0"/>
+              <a:t>각 컴포넌트는 </a:t>
+            </a:r>
+            <a:r>
+              <a:rPr lang="en-US" altLang="ko-KR" dirty="0"/>
+              <a:t>Virtual DOM</a:t>
+            </a:r>
+            <a:r>
+              <a:rPr lang="ko-KR" altLang="en-US" dirty="0"/>
+              <a:t>에 대응하는 가상 </a:t>
+            </a:r>
+            <a:r>
+              <a:rPr lang="en-US" altLang="ko-KR" dirty="0"/>
+              <a:t>DOM </a:t>
+            </a:r>
+            <a:r>
+              <a:rPr lang="ko-KR" altLang="en-US" dirty="0"/>
+              <a:t>트리를 생성</a:t>
+            </a:r>
+            <a:r>
+              <a:rPr lang="en-US" altLang="ko-KR" dirty="0"/>
+              <a:t>.</a:t>
+            </a:r>
+          </a:p>
+          <a:p>
+            <a:pPr marL="171450" indent="-171450">
+              <a:buFont typeface="Wingdings" panose="05000000000000000000" pitchFamily="2" charset="2"/>
+              <a:buChar char="n"/>
+            </a:pPr>
+            <a:r>
+              <a:rPr lang="ko-KR" altLang="en-US" dirty="0"/>
+              <a:t>이 가상 </a:t>
+            </a:r>
+            <a:r>
+              <a:rPr lang="en-US" altLang="ko-KR" dirty="0"/>
+              <a:t>DOM </a:t>
+            </a:r>
+            <a:r>
+              <a:rPr lang="ko-KR" altLang="en-US" dirty="0"/>
+              <a:t>트리는 </a:t>
+            </a:r>
+            <a:r>
+              <a:rPr lang="en-US" altLang="ko-KR" dirty="0"/>
+              <a:t>React </a:t>
+            </a:r>
+            <a:r>
+              <a:rPr lang="ko-KR" altLang="en-US" dirty="0"/>
+              <a:t>요소와 컴포넌트의 상태 및 속성에 대한 정보를 담고 있음</a:t>
+            </a:r>
+            <a:r>
+              <a:rPr lang="en-US" altLang="ko-KR" dirty="0"/>
+              <a:t>.</a:t>
+            </a:r>
+          </a:p>
+          <a:p>
+            <a:pPr marL="171450" indent="-171450">
+              <a:buFont typeface="Wingdings" panose="05000000000000000000" pitchFamily="2" charset="2"/>
+              <a:buChar char="n"/>
+            </a:pPr>
+            <a:endParaRPr lang="en-US" altLang="ko-KR" dirty="0"/>
+          </a:p>
+          <a:p>
+            <a:pPr marL="0" indent="0">
+              <a:buFont typeface="Wingdings" panose="05000000000000000000" pitchFamily="2" charset="2"/>
+              <a:buNone/>
+            </a:pPr>
+            <a:r>
+              <a:rPr lang="en-US" altLang="ko-KR" dirty="0"/>
+              <a:t>2. </a:t>
+            </a:r>
+            <a:r>
+              <a:rPr lang="ko-KR" altLang="en-US" dirty="0"/>
+              <a:t>실제 </a:t>
+            </a:r>
+            <a:r>
+              <a:rPr lang="en-US" altLang="ko-KR" dirty="0"/>
+              <a:t>DOM </a:t>
+            </a:r>
+            <a:r>
+              <a:rPr lang="ko-KR" altLang="en-US" dirty="0"/>
+              <a:t>과 비교</a:t>
+            </a:r>
+            <a:endParaRPr lang="en-US" altLang="ko-KR" dirty="0"/>
+          </a:p>
+          <a:p>
+            <a:pPr marL="171450" indent="-171450">
+              <a:buFont typeface="Wingdings" panose="05000000000000000000" pitchFamily="2" charset="2"/>
+              <a:buChar char="n"/>
+            </a:pPr>
+            <a:r>
+              <a:rPr lang="ko-KR" altLang="en-US" dirty="0"/>
+              <a:t>상태가 변경되면 </a:t>
+            </a:r>
+            <a:r>
+              <a:rPr lang="en-US" altLang="ko-KR" dirty="0"/>
+              <a:t>React</a:t>
+            </a:r>
+            <a:r>
+              <a:rPr lang="ko-KR" altLang="en-US" dirty="0"/>
+              <a:t>는 기존의 가상 </a:t>
+            </a:r>
+            <a:r>
+              <a:rPr lang="en-US" altLang="ko-KR" dirty="0"/>
+              <a:t>DOM </a:t>
+            </a:r>
+            <a:r>
+              <a:rPr lang="ko-KR" altLang="en-US" dirty="0"/>
+              <a:t>트리와 새로운 가상 </a:t>
+            </a:r>
+            <a:r>
+              <a:rPr lang="en-US" altLang="ko-KR" dirty="0"/>
+              <a:t>DOM </a:t>
+            </a:r>
+            <a:r>
+              <a:rPr lang="ko-KR" altLang="en-US" dirty="0"/>
+              <a:t>트리를 비교함</a:t>
+            </a:r>
+            <a:r>
+              <a:rPr lang="en-US" altLang="ko-KR" dirty="0"/>
+              <a:t>.</a:t>
+            </a:r>
+          </a:p>
+          <a:p>
+            <a:pPr marL="171450" indent="-171450">
+              <a:buFont typeface="Wingdings" panose="05000000000000000000" pitchFamily="2" charset="2"/>
+              <a:buChar char="n"/>
+            </a:pPr>
+            <a:r>
+              <a:rPr lang="ko-KR" altLang="en-US" dirty="0"/>
+              <a:t>이 과정에서 변경된 부분만을 실제 </a:t>
+            </a:r>
+            <a:r>
+              <a:rPr lang="en-US" altLang="ko-KR" dirty="0"/>
+              <a:t>DOM </a:t>
+            </a:r>
+            <a:r>
+              <a:rPr lang="ko-KR" altLang="en-US" dirty="0"/>
+              <a:t>에 반영하고</a:t>
+            </a:r>
+            <a:r>
+              <a:rPr lang="en-US" altLang="ko-KR" dirty="0"/>
+              <a:t>, </a:t>
+            </a:r>
+            <a:r>
+              <a:rPr lang="ko-KR" altLang="en-US" dirty="0"/>
+              <a:t>필요한 경우에만 실제 </a:t>
+            </a:r>
+            <a:r>
+              <a:rPr lang="en-US" altLang="ko-KR" dirty="0"/>
+              <a:t>DOM</a:t>
+            </a:r>
+            <a:r>
+              <a:rPr lang="ko-KR" altLang="en-US" dirty="0"/>
+              <a:t>을 업데이트 함</a:t>
+            </a:r>
+            <a:r>
+              <a:rPr lang="en-US" altLang="ko-KR" dirty="0"/>
+              <a:t>.</a:t>
+            </a:r>
+          </a:p>
+          <a:p>
+            <a:pPr marL="171450" indent="-171450">
+              <a:buFont typeface="Wingdings" panose="05000000000000000000" pitchFamily="2" charset="2"/>
+              <a:buChar char="n"/>
+            </a:pPr>
+            <a:r>
+              <a:rPr lang="ko-KR" altLang="en-US" dirty="0"/>
+              <a:t>이는 전체적인 렌더링의 성능을 향상시키고</a:t>
+            </a:r>
+            <a:r>
+              <a:rPr lang="en-US" altLang="ko-KR" dirty="0"/>
+              <a:t>, </a:t>
+            </a:r>
+            <a:r>
+              <a:rPr lang="ko-KR" altLang="en-US" dirty="0"/>
+              <a:t>불필요한 </a:t>
+            </a:r>
+            <a:r>
+              <a:rPr lang="en-US" altLang="ko-KR" dirty="0"/>
+              <a:t>DOM </a:t>
+            </a:r>
+            <a:r>
+              <a:rPr lang="ko-KR" altLang="en-US" dirty="0"/>
+              <a:t>조작을 </a:t>
+            </a:r>
+            <a:r>
+              <a:rPr lang="ko-KR" altLang="en-US" dirty="0" err="1"/>
+              <a:t>줄여줌</a:t>
+            </a:r>
+            <a:r>
+              <a:rPr lang="en-US" altLang="ko-KR" dirty="0"/>
+              <a:t>.</a:t>
+            </a:r>
+          </a:p>
+          <a:p>
+            <a:pPr marL="171450" indent="-171450">
+              <a:buFont typeface="Wingdings" panose="05000000000000000000" pitchFamily="2" charset="2"/>
+              <a:buChar char="n"/>
+            </a:pPr>
+            <a:endParaRPr lang="en-US" altLang="ko-KR" dirty="0"/>
+          </a:p>
+          <a:p>
+            <a:pPr marL="0" indent="0">
+              <a:buFont typeface="Wingdings" panose="05000000000000000000" pitchFamily="2" charset="2"/>
+              <a:buNone/>
+            </a:pPr>
+            <a:r>
+              <a:rPr lang="en-US" altLang="ko-KR" dirty="0"/>
+              <a:t>3. </a:t>
+            </a:r>
+            <a:r>
+              <a:rPr lang="ko-KR" altLang="en-US" dirty="0"/>
+              <a:t>성능 최적화</a:t>
+            </a:r>
+            <a:endParaRPr lang="en-US" altLang="ko-KR" dirty="0"/>
+          </a:p>
+          <a:p>
+            <a:pPr marL="171450" indent="-171450">
+              <a:buFont typeface="Wingdings" panose="05000000000000000000" pitchFamily="2" charset="2"/>
+              <a:buChar char="n"/>
+            </a:pPr>
+            <a:r>
+              <a:rPr lang="en-US" altLang="ko-KR" dirty="0"/>
+              <a:t>Virtual DOM</a:t>
+            </a:r>
+            <a:r>
+              <a:rPr lang="ko-KR" altLang="en-US" dirty="0"/>
+              <a:t>은 실제 </a:t>
+            </a:r>
+            <a:r>
+              <a:rPr lang="en-US" altLang="ko-KR" dirty="0"/>
+              <a:t>DOM </a:t>
+            </a:r>
+            <a:r>
+              <a:rPr lang="ko-KR" altLang="en-US" dirty="0"/>
+              <a:t>조작보다 빠르게 작동할 수 있음</a:t>
+            </a:r>
+            <a:r>
+              <a:rPr lang="en-US" altLang="ko-KR" dirty="0"/>
+              <a:t>. </a:t>
+            </a:r>
+            <a:r>
+              <a:rPr lang="ko-KR" altLang="en-US" dirty="0"/>
+              <a:t>이는 가상 </a:t>
+            </a:r>
+            <a:r>
+              <a:rPr lang="en-US" altLang="ko-KR" dirty="0"/>
+              <a:t>DOM</a:t>
+            </a:r>
+            <a:r>
+              <a:rPr lang="ko-KR" altLang="en-US" dirty="0"/>
+              <a:t>의 변경 내용을 실제 </a:t>
+            </a:r>
+            <a:r>
+              <a:rPr lang="en-US" altLang="ko-KR" dirty="0"/>
+              <a:t>DOM</a:t>
+            </a:r>
+            <a:r>
+              <a:rPr lang="ko-KR" altLang="en-US" dirty="0"/>
+              <a:t>에 일괄적으로 적용하거나</a:t>
+            </a:r>
+            <a:r>
+              <a:rPr lang="en-US" altLang="ko-KR" dirty="0"/>
+              <a:t>, </a:t>
+            </a:r>
+            <a:r>
+              <a:rPr lang="ko-KR" altLang="en-US" dirty="0"/>
+              <a:t>최적화된 방식으로 변경 사항을 처리함으로써 가능</a:t>
+            </a:r>
+            <a:r>
+              <a:rPr lang="en-US" altLang="ko-KR" dirty="0"/>
+              <a:t>.</a:t>
+            </a:r>
+          </a:p>
+          <a:p>
+            <a:pPr marL="171450" indent="-171450">
+              <a:buFont typeface="Wingdings" panose="05000000000000000000" pitchFamily="2" charset="2"/>
+              <a:buChar char="n"/>
+            </a:pPr>
+            <a:r>
+              <a:rPr lang="ko-KR" altLang="en-US" dirty="0"/>
+              <a:t>또한 </a:t>
+            </a:r>
+            <a:r>
+              <a:rPr lang="en-US" altLang="ko-KR" dirty="0"/>
+              <a:t>React</a:t>
+            </a:r>
+            <a:r>
+              <a:rPr lang="ko-KR" altLang="en-US" dirty="0"/>
+              <a:t>는 가상 </a:t>
+            </a:r>
+            <a:r>
+              <a:rPr lang="en-US" altLang="ko-KR" dirty="0"/>
+              <a:t>DOM</a:t>
+            </a:r>
+            <a:r>
+              <a:rPr lang="ko-KR" altLang="en-US" dirty="0"/>
+              <a:t>을 통해 효율적인 배치와 렌더링 최적화를 수행할 수 있다</a:t>
+            </a:r>
+            <a:r>
+              <a:rPr lang="en-US" altLang="ko-KR" dirty="0"/>
+              <a:t>.</a:t>
+            </a:r>
+          </a:p>
+          <a:p>
+            <a:pPr marL="171450" indent="-171450">
+              <a:buFont typeface="Wingdings" panose="05000000000000000000" pitchFamily="2" charset="2"/>
+              <a:buChar char="n"/>
+            </a:pPr>
+            <a:endParaRPr lang="en-US" altLang="ko-KR" dirty="0"/>
+          </a:p>
+          <a:p>
+            <a:pPr marL="0" indent="0">
+              <a:buFont typeface="Wingdings" panose="05000000000000000000" pitchFamily="2" charset="2"/>
+              <a:buNone/>
+            </a:pPr>
+            <a:r>
+              <a:rPr lang="en-US" altLang="ko-KR" dirty="0"/>
+              <a:t>4. </a:t>
+            </a:r>
+            <a:r>
+              <a:rPr lang="ko-KR" altLang="en-US" dirty="0"/>
+              <a:t>자동화된 업데이트</a:t>
+            </a:r>
+            <a:endParaRPr lang="en-US" altLang="ko-KR" dirty="0"/>
+          </a:p>
+          <a:p>
+            <a:pPr marL="171450" indent="-171450">
+              <a:buFont typeface="Wingdings" panose="05000000000000000000" pitchFamily="2" charset="2"/>
+              <a:buChar char="n"/>
+            </a:pPr>
+            <a:r>
+              <a:rPr lang="ko-KR" altLang="en-US" dirty="0"/>
+              <a:t>개발자는 직접적으로 실제 </a:t>
+            </a:r>
+            <a:r>
+              <a:rPr lang="en-US" altLang="ko-KR" dirty="0"/>
+              <a:t>DOM</a:t>
+            </a:r>
+            <a:r>
+              <a:rPr lang="ko-KR" altLang="en-US" dirty="0"/>
+              <a:t>을 조작하는 대신</a:t>
+            </a:r>
+            <a:r>
+              <a:rPr lang="en-US" altLang="ko-KR" dirty="0"/>
+              <a:t>, React </a:t>
+            </a:r>
+            <a:r>
+              <a:rPr lang="ko-KR" altLang="en-US" dirty="0"/>
+              <a:t>컴포넌트의 상태를 업데이트하면 </a:t>
+            </a:r>
+            <a:r>
+              <a:rPr lang="en-US" altLang="ko-KR" dirty="0"/>
+              <a:t>React</a:t>
+            </a:r>
+            <a:r>
+              <a:rPr lang="ko-KR" altLang="en-US" dirty="0"/>
+              <a:t>가 알아서 가상 </a:t>
+            </a:r>
+            <a:r>
+              <a:rPr lang="en-US" altLang="ko-KR" dirty="0"/>
+              <a:t>DOM</a:t>
+            </a:r>
+            <a:r>
+              <a:rPr lang="ko-KR" altLang="en-US" dirty="0"/>
+              <a:t>을 업데이트하고 이를  실제 </a:t>
+            </a:r>
+            <a:r>
+              <a:rPr lang="en-US" altLang="ko-KR" dirty="0"/>
+              <a:t>DOM</a:t>
+            </a:r>
+            <a:r>
+              <a:rPr lang="ko-KR" altLang="en-US" dirty="0"/>
+              <a:t>에 반영함</a:t>
+            </a:r>
+            <a:r>
+              <a:rPr lang="en-US" altLang="ko-KR" dirty="0"/>
+              <a:t>.</a:t>
+            </a:r>
+          </a:p>
+          <a:p>
+            <a:pPr marL="171450" indent="-171450">
+              <a:buFont typeface="Wingdings" panose="05000000000000000000" pitchFamily="2" charset="2"/>
+              <a:buChar char="n"/>
+            </a:pPr>
+            <a:r>
+              <a:rPr lang="ko-KR" altLang="en-US" dirty="0"/>
+              <a:t>이로 인해 코드의 복잡성을 줄이고</a:t>
+            </a:r>
+            <a:r>
+              <a:rPr lang="en-US" altLang="ko-KR" dirty="0"/>
+              <a:t>, </a:t>
+            </a:r>
+            <a:r>
+              <a:rPr lang="ko-KR" altLang="en-US" dirty="0"/>
+              <a:t>버그 발생 가능성을 낮출 수 있음</a:t>
+            </a:r>
+            <a:r>
+              <a:rPr lang="en-US" altLang="ko-KR" dirty="0"/>
+              <a:t>.</a:t>
+            </a:r>
           </a:p>
         </p:txBody>
       </p:sp>
@@ -894,7 +1548,7 @@
           <a:p>
             <a:fld id="{C09E5BFC-1559-42F1-8940-AB342D56BF02}" type="slidenum">
               <a:rPr lang="ko-KR" altLang="en-US" smtClean="0"/>
-              <a:t>21</a:t>
+              <a:t>16</a:t>
             </a:fld>
             <a:endParaRPr lang="ko-KR" altLang="en-US"/>
           </a:p>
@@ -903,7 +1557,7 @@
     </p:spTree>
     <p:extLst>
       <p:ext uri="{BB962C8B-B14F-4D97-AF65-F5344CB8AC3E}">
-        <p14:creationId xmlns:p14="http://schemas.microsoft.com/office/powerpoint/2010/main" val="4258613479"/>
+        <p14:creationId xmlns:p14="http://schemas.microsoft.com/office/powerpoint/2010/main" val="3695344237"/>
       </p:ext>
     </p:extLst>
   </p:cSld>
@@ -968,7 +1622,7 @@
             <a:spLocks noGrp="1"/>
           </p:cNvSpPr>
           <p:nvPr>
-            <p:ph type="sldNum" sz="quarter" idx="5"/>
+            <p:ph type="sldNum" sz="quarter" idx="10"/>
           </p:nvPr>
         </p:nvSpPr>
         <p:spPr/>
@@ -978,7 +1632,7 @@
           <a:p>
             <a:fld id="{C09E5BFC-1559-42F1-8940-AB342D56BF02}" type="slidenum">
               <a:rPr lang="ko-KR" altLang="en-US" smtClean="0"/>
-              <a:t>23</a:t>
+              <a:t>18</a:t>
             </a:fld>
             <a:endParaRPr lang="ko-KR" altLang="en-US"/>
           </a:p>
@@ -987,7 +1641,7 @@
     </p:spTree>
     <p:extLst>
       <p:ext uri="{BB962C8B-B14F-4D97-AF65-F5344CB8AC3E}">
-        <p14:creationId xmlns:p14="http://schemas.microsoft.com/office/powerpoint/2010/main" val="2523697781"/>
+        <p14:creationId xmlns:p14="http://schemas.microsoft.com/office/powerpoint/2010/main" val="2852263773"/>
       </p:ext>
     </p:extLst>
   </p:cSld>
@@ -1062,7 +1716,7 @@
           <a:p>
             <a:fld id="{C09E5BFC-1559-42F1-8940-AB342D56BF02}" type="slidenum">
               <a:rPr lang="ko-KR" altLang="en-US" smtClean="0"/>
-              <a:t>24</a:t>
+              <a:t>19</a:t>
             </a:fld>
             <a:endParaRPr lang="ko-KR" altLang="en-US"/>
           </a:p>
@@ -1071,7 +1725,7 @@
     </p:spTree>
     <p:extLst>
       <p:ext uri="{BB962C8B-B14F-4D97-AF65-F5344CB8AC3E}">
-        <p14:creationId xmlns:p14="http://schemas.microsoft.com/office/powerpoint/2010/main" val="3875432298"/>
+        <p14:creationId xmlns:p14="http://schemas.microsoft.com/office/powerpoint/2010/main" val="3247079256"/>
       </p:ext>
     </p:extLst>
   </p:cSld>
@@ -1125,169 +1779,8 @@
           <a:bodyPr/>
           <a:lstStyle/>
           <a:p>
-            <a:r>
-              <a:rPr lang="en-US" altLang="ko-KR" dirty="0" err="1"/>
-              <a:t>npx</a:t>
-            </a:r>
-            <a:r>
-              <a:rPr lang="en-US" altLang="ko-KR" dirty="0"/>
-              <a:t> </a:t>
-            </a:r>
-            <a:r>
-              <a:rPr lang="ko-KR" altLang="en-US" dirty="0"/>
-              <a:t>변경사항이</a:t>
-            </a:r>
-            <a:r>
-              <a:rPr lang="ko-KR" altLang="en-US" baseline="0" dirty="0"/>
-              <a:t> 잦은 모듈을 사용할 때</a:t>
-            </a:r>
-            <a:r>
-              <a:rPr lang="en-US" altLang="ko-KR" baseline="0" dirty="0"/>
-              <a:t>, </a:t>
-            </a:r>
-            <a:r>
-              <a:rPr lang="ko-KR" altLang="en-US" baseline="0" dirty="0"/>
-              <a:t>매번 최신 버전을 설치하지 않도록 모듈을 로컬에 저장하지 않고 매번 최신 버전의 파일만을 불러와 실행시키는 방식</a:t>
-            </a:r>
-            <a:r>
-              <a:rPr lang="en-US" altLang="ko-KR" baseline="0" dirty="0"/>
-              <a:t>. </a:t>
-            </a:r>
-            <a:r>
-              <a:rPr lang="ko-KR" altLang="en-US" baseline="0" dirty="0"/>
-              <a:t>원래 </a:t>
-            </a:r>
-            <a:r>
-              <a:rPr lang="en-US" altLang="ko-KR" baseline="0" dirty="0" err="1"/>
-              <a:t>npm</a:t>
-            </a:r>
-            <a:r>
-              <a:rPr lang="ko-KR" altLang="en-US" baseline="0" dirty="0"/>
-              <a:t>으로 설치 후에 </a:t>
-            </a:r>
-            <a:r>
-              <a:rPr lang="ko-KR" altLang="en-US" baseline="0" dirty="0" err="1"/>
-              <a:t>사용해야하지만</a:t>
-            </a:r>
-            <a:r>
-              <a:rPr lang="ko-KR" altLang="en-US" baseline="0" dirty="0"/>
-              <a:t> </a:t>
-            </a:r>
-            <a:r>
-              <a:rPr lang="en-US" altLang="ko-KR" baseline="0" dirty="0" err="1"/>
-              <a:t>npm</a:t>
-            </a:r>
-            <a:r>
-              <a:rPr lang="en-US" altLang="ko-KR" baseline="0" dirty="0"/>
-              <a:t> 5.2.0 </a:t>
-            </a:r>
-            <a:r>
-              <a:rPr lang="ko-KR" altLang="en-US" baseline="0" dirty="0"/>
-              <a:t>버전부터 추가된 패키지 사용 도구</a:t>
-            </a:r>
-            <a:endParaRPr lang="en-US" altLang="ko-KR" baseline="0" dirty="0"/>
-          </a:p>
-          <a:p>
-            <a:endParaRPr lang="en-US" altLang="ko-KR" baseline="0" dirty="0"/>
-          </a:p>
-          <a:p>
-            <a:r>
-              <a:rPr lang="en-US" altLang="ko-KR" baseline="0" dirty="0"/>
-              <a:t>yarn: </a:t>
-            </a:r>
-            <a:r>
-              <a:rPr lang="en-US" altLang="ko-KR" baseline="0" dirty="0" err="1"/>
-              <a:t>npm</a:t>
-            </a:r>
-            <a:r>
-              <a:rPr lang="en-US" altLang="ko-KR" baseline="0" dirty="0"/>
-              <a:t> </a:t>
-            </a:r>
-            <a:r>
-              <a:rPr lang="ko-KR" altLang="en-US" baseline="0" dirty="0"/>
-              <a:t>처럼 사용하는 </a:t>
-            </a:r>
-            <a:r>
-              <a:rPr lang="en-US" altLang="ko-KR" baseline="0" dirty="0" err="1"/>
-              <a:t>facebook</a:t>
-            </a:r>
-            <a:r>
-              <a:rPr lang="en-US" altLang="ko-KR" baseline="0" dirty="0"/>
-              <a:t> </a:t>
-            </a:r>
-            <a:r>
-              <a:rPr lang="ko-KR" altLang="en-US" baseline="0" dirty="0"/>
-              <a:t>에서 만든 자바스크립트 패키지 매니저</a:t>
-            </a:r>
-            <a:r>
-              <a:rPr lang="en-US" altLang="ko-KR" baseline="0" dirty="0"/>
-              <a:t>, </a:t>
-            </a:r>
-            <a:r>
-              <a:rPr lang="en-US" altLang="ko-KR" baseline="0" dirty="0" err="1"/>
-              <a:t>npm</a:t>
-            </a:r>
-            <a:r>
-              <a:rPr lang="ko-KR" altLang="en-US" baseline="0" dirty="0"/>
-              <a:t>보다 빠르고 효율적임</a:t>
-            </a:r>
-            <a:r>
-              <a:rPr lang="en-US" altLang="ko-KR" baseline="0" dirty="0"/>
-              <a:t>. </a:t>
-            </a:r>
-            <a:r>
-              <a:rPr lang="ko-KR" altLang="en-US" baseline="0" dirty="0"/>
-              <a:t>하지만 </a:t>
-            </a:r>
-            <a:r>
-              <a:rPr lang="en-US" altLang="ko-KR" baseline="0" dirty="0" err="1"/>
-              <a:t>npm</a:t>
-            </a:r>
-            <a:r>
-              <a:rPr lang="ko-KR" altLang="en-US" baseline="0" dirty="0"/>
-              <a:t>이 기본이기 때문에 일단은 계속 </a:t>
-            </a:r>
-            <a:r>
-              <a:rPr lang="en-US" altLang="ko-KR" baseline="0" dirty="0" err="1"/>
-              <a:t>npm</a:t>
-            </a:r>
-            <a:r>
-              <a:rPr lang="ko-KR" altLang="en-US" baseline="0" dirty="0"/>
-              <a:t>으로 사용할 예정</a:t>
-            </a:r>
-            <a:r>
-              <a:rPr lang="en-US" altLang="ko-KR" baseline="0" dirty="0"/>
-              <a:t>. </a:t>
-            </a:r>
-            <a:r>
-              <a:rPr lang="ko-KR" altLang="en-US" baseline="0" dirty="0"/>
-              <a:t>나중에 공부하다가 </a:t>
-            </a:r>
-            <a:r>
-              <a:rPr lang="en-US" altLang="ko-KR" baseline="0" dirty="0"/>
-              <a:t>yarn</a:t>
-            </a:r>
-            <a:r>
-              <a:rPr lang="ko-KR" altLang="en-US" baseline="0" dirty="0"/>
-              <a:t>을 만나면 당황하지 말고 </a:t>
-            </a:r>
-            <a:r>
-              <a:rPr lang="en-US" altLang="ko-KR" baseline="0" dirty="0" err="1"/>
-              <a:t>npm</a:t>
-            </a:r>
-            <a:r>
-              <a:rPr lang="en-US" altLang="ko-KR" baseline="0" dirty="0"/>
-              <a:t> </a:t>
-            </a:r>
-            <a:r>
-              <a:rPr lang="ko-KR" altLang="en-US" baseline="0" dirty="0"/>
-              <a:t>처럼 쓰이는 친구라고 생각하면 됨</a:t>
-            </a:r>
             <a:endParaRPr lang="ko-KR" altLang="en-US" dirty="0"/>
           </a:p>
-          <a:p>
-            <a:endParaRPr lang="ko-KR" altLang="en-US" dirty="0"/>
-          </a:p>
         </p:txBody>
       </p:sp>
       <p:sp>
@@ -1297,7 +1790,7 @@
             <a:spLocks noGrp="1"/>
           </p:cNvSpPr>
           <p:nvPr>
-            <p:ph type="sldNum" sz="quarter" idx="10"/>
+            <p:ph type="sldNum" sz="quarter" idx="5"/>
           </p:nvPr>
         </p:nvSpPr>
         <p:spPr/>
@@ -1307,7 +1800,7 @@
           <a:p>
             <a:fld id="{C09E5BFC-1559-42F1-8940-AB342D56BF02}" type="slidenum">
               <a:rPr lang="ko-KR" altLang="en-US" smtClean="0"/>
-              <a:t>25</a:t>
+              <a:t>21</a:t>
             </a:fld>
             <a:endParaRPr lang="ko-KR" altLang="en-US"/>
           </a:p>
@@ -1316,7 +1809,7 @@
     </p:spTree>
     <p:extLst>
       <p:ext uri="{BB962C8B-B14F-4D97-AF65-F5344CB8AC3E}">
-        <p14:creationId xmlns:p14="http://schemas.microsoft.com/office/powerpoint/2010/main" val="3910243359"/>
+        <p14:creationId xmlns:p14="http://schemas.microsoft.com/office/powerpoint/2010/main" val="4258613479"/>
       </p:ext>
     </p:extLst>
   </p:cSld>
@@ -1391,7 +1884,7 @@
           <a:p>
             <a:fld id="{C09E5BFC-1559-42F1-8940-AB342D56BF02}" type="slidenum">
               <a:rPr lang="ko-KR" altLang="en-US" smtClean="0"/>
-              <a:t>26</a:t>
+              <a:t>23</a:t>
             </a:fld>
             <a:endParaRPr lang="ko-KR" altLang="en-US"/>
           </a:p>
@@ -1400,7 +1893,7 @@
     </p:spTree>
     <p:extLst>
       <p:ext uri="{BB962C8B-B14F-4D97-AF65-F5344CB8AC3E}">
-        <p14:creationId xmlns:p14="http://schemas.microsoft.com/office/powerpoint/2010/main" val="1615425653"/>
+        <p14:creationId xmlns:p14="http://schemas.microsoft.com/office/powerpoint/2010/main" val="2523697781"/>
       </p:ext>
     </p:extLst>
   </p:cSld>
@@ -1454,246 +1947,8 @@
           <a:bodyPr/>
           <a:lstStyle/>
           <a:p>
-            <a:pPr>
-              <a:buFont typeface="Arial" panose="020B0604020202020204" pitchFamily="34" charset="0"/>
-              <a:buChar char="•"/>
-            </a:pPr>
-            <a:r>
-              <a:rPr lang="ko-KR" altLang="en-US" dirty="0"/>
-              <a:t>**</a:t>
-            </a:r>
-            <a:r>
-              <a:rPr lang="en-US" altLang="ko-KR" dirty="0" err="1"/>
-              <a:t>package.json</a:t>
-            </a:r>
-            <a:r>
-              <a:rPr lang="en-US" altLang="ko-KR" dirty="0"/>
-              <a:t>** </a:t>
-            </a:r>
-          </a:p>
-          <a:p>
-            <a:pPr marL="742950" lvl="1" indent="-285750">
-              <a:buFont typeface="Arial" panose="020B0604020202020204" pitchFamily="34" charset="0"/>
-              <a:buChar char="•"/>
-            </a:pPr>
-            <a:r>
-              <a:rPr lang="ko-KR" altLang="en-US" dirty="0"/>
-              <a:t>이 프로젝트의 메타 데이터</a:t>
-            </a:r>
-          </a:p>
-          <a:p>
-            <a:pPr marL="742950" lvl="1" indent="-285750">
-              <a:buFont typeface="Arial" panose="020B0604020202020204" pitchFamily="34" charset="0"/>
-              <a:buChar char="•"/>
-            </a:pPr>
-            <a:r>
-              <a:rPr lang="ko-KR" altLang="en-US" dirty="0"/>
-              <a:t>사용할 </a:t>
-            </a:r>
-            <a:r>
-              <a:rPr lang="en-US" altLang="ko-KR" dirty="0"/>
-              <a:t>node.js </a:t>
-            </a:r>
-            <a:r>
-              <a:rPr lang="ko-KR" altLang="en-US" dirty="0"/>
-              <a:t>패키지 목록 등을 </a:t>
-            </a:r>
-            <a:r>
-              <a:rPr lang="ko-KR" altLang="en-US" dirty="0" err="1"/>
-              <a:t>퐇마</a:t>
-            </a:r>
             <a:endParaRPr lang="ko-KR" altLang="en-US" dirty="0"/>
           </a:p>
-          <a:p>
-            <a:pPr>
-              <a:buFont typeface="Arial" panose="020B0604020202020204" pitchFamily="34" charset="0"/>
-              <a:buChar char="•"/>
-            </a:pPr>
-            <a:r>
-              <a:rPr lang="ko-KR" altLang="en-US" dirty="0"/>
-              <a:t>**</a:t>
-            </a:r>
-            <a:r>
-              <a:rPr lang="en-US" altLang="ko-KR" dirty="0"/>
-              <a:t>public/** </a:t>
-            </a:r>
-          </a:p>
-          <a:p>
-            <a:pPr marL="742950" lvl="1" indent="-285750">
-              <a:buFont typeface="Arial" panose="020B0604020202020204" pitchFamily="34" charset="0"/>
-              <a:buChar char="•"/>
-            </a:pPr>
-            <a:r>
-              <a:rPr lang="en-US" altLang="ko-KR" b="1" dirty="0"/>
-              <a:t>index.html</a:t>
-            </a:r>
-            <a:r>
-              <a:rPr lang="en-US" altLang="ko-KR" dirty="0"/>
-              <a:t>: </a:t>
-            </a:r>
-            <a:r>
-              <a:rPr lang="en-US" altLang="ko-KR" dirty="0">
-                <a:hlinkClick r:id="rId3"/>
-              </a:rPr>
-              <a:t>http://localhost:3000</a:t>
-            </a:r>
-            <a:r>
-              <a:rPr lang="ko-KR" altLang="en-US" dirty="0"/>
-              <a:t> 이 가장 먼저 </a:t>
-            </a:r>
-            <a:r>
-              <a:rPr lang="ko-KR" altLang="en-US" dirty="0" err="1"/>
-              <a:t>리턴하는</a:t>
-            </a:r>
-            <a:r>
-              <a:rPr lang="ko-KR" altLang="en-US" dirty="0"/>
-              <a:t> 파일 </a:t>
-            </a:r>
-          </a:p>
-          <a:p>
-            <a:pPr marL="1143000" lvl="2" indent="-228600">
-              <a:buFont typeface="Arial" panose="020B0604020202020204" pitchFamily="34" charset="0"/>
-              <a:buChar char="•"/>
-            </a:pPr>
-            <a:r>
-              <a:rPr lang="ko-KR" altLang="en-US" dirty="0"/>
-              <a:t>현재 유일한 </a:t>
-            </a:r>
-            <a:r>
-              <a:rPr lang="en-US" altLang="ko-KR" dirty="0"/>
-              <a:t>html </a:t>
-            </a:r>
-            <a:r>
-              <a:rPr lang="ko-KR" altLang="en-US" dirty="0"/>
-              <a:t>파일</a:t>
-            </a:r>
-          </a:p>
-          <a:p>
-            <a:pPr marL="742950" lvl="1" indent="-285750">
-              <a:buFont typeface="Arial" panose="020B0604020202020204" pitchFamily="34" charset="0"/>
-              <a:buChar char="•"/>
-            </a:pPr>
-            <a:r>
-              <a:rPr lang="ko-KR" altLang="en-US" dirty="0"/>
-              <a:t>다른 페이지들은 </a:t>
-            </a:r>
-            <a:r>
-              <a:rPr lang="en-US" altLang="ko-KR" dirty="0"/>
-              <a:t>React.js</a:t>
-            </a:r>
-            <a:r>
-              <a:rPr lang="ko-KR" altLang="en-US" dirty="0"/>
-              <a:t>를 통해 생성되어 </a:t>
-            </a:r>
-            <a:r>
-              <a:rPr lang="en-US" altLang="ko-KR" dirty="0"/>
-              <a:t>&lt;div id="root"&gt; </a:t>
-            </a:r>
-            <a:r>
-              <a:rPr lang="ko-KR" altLang="en-US" dirty="0"/>
-              <a:t>요소 아래에 동적으로 렌더링 됨</a:t>
-            </a:r>
-          </a:p>
-          <a:p>
-            <a:pPr>
-              <a:buFont typeface="Arial" panose="020B0604020202020204" pitchFamily="34" charset="0"/>
-              <a:buChar char="•"/>
-            </a:pPr>
-            <a:r>
-              <a:rPr lang="ko-KR" altLang="en-US" dirty="0"/>
-              <a:t>**</a:t>
-            </a:r>
-            <a:r>
-              <a:rPr lang="en-US" altLang="ko-KR" dirty="0" err="1"/>
-              <a:t>src</a:t>
-            </a:r>
-            <a:r>
-              <a:rPr lang="en-US" altLang="ko-KR" dirty="0"/>
-              <a:t>/** </a:t>
-            </a:r>
-          </a:p>
-          <a:p>
-            <a:pPr marL="742950" lvl="1" indent="-285750">
-              <a:buFont typeface="Arial" panose="020B0604020202020204" pitchFamily="34" charset="0"/>
-              <a:buChar char="•"/>
-            </a:pPr>
-            <a:r>
-              <a:rPr lang="en-US" altLang="ko-KR" dirty="0"/>
-              <a:t>**index.js** </a:t>
-            </a:r>
-          </a:p>
-          <a:p>
-            <a:pPr marL="1143000" lvl="2" indent="-228600">
-              <a:buFont typeface="Arial" panose="020B0604020202020204" pitchFamily="34" charset="0"/>
-              <a:buChar char="•"/>
-            </a:pPr>
-            <a:r>
-              <a:rPr lang="en-US" altLang="ko-KR" dirty="0"/>
-              <a:t>index.html</a:t>
-            </a:r>
-            <a:r>
-              <a:rPr lang="ko-KR" altLang="en-US" dirty="0"/>
-              <a:t>과 함께 가장 처음으로 실행 되는 자바스크립트 코드</a:t>
-            </a:r>
-          </a:p>
-          <a:p>
-            <a:pPr marL="1143000" lvl="2" indent="-228600">
-              <a:buFont typeface="Arial" panose="020B0604020202020204" pitchFamily="34" charset="0"/>
-              <a:buChar char="•"/>
-            </a:pPr>
-            <a:r>
-              <a:rPr lang="ko-KR" altLang="en-US" dirty="0"/>
-              <a:t>이 자바스크립트 코드가 </a:t>
-            </a:r>
-            <a:r>
-              <a:rPr lang="ko-KR" altLang="en-US" dirty="0" err="1"/>
-              <a:t>리액트</a:t>
-            </a:r>
-            <a:r>
-              <a:rPr lang="ko-KR" altLang="en-US" dirty="0"/>
-              <a:t> 컴포넌트를 </a:t>
-            </a:r>
-            <a:r>
-              <a:rPr lang="en-US" altLang="ko-KR" dirty="0"/>
-              <a:t>root </a:t>
-            </a:r>
-            <a:r>
-              <a:rPr lang="ko-KR" altLang="en-US" dirty="0"/>
-              <a:t>아래에 추가</a:t>
-            </a:r>
-          </a:p>
-          <a:p>
-            <a:pPr marL="742950" lvl="1" indent="-285750">
-              <a:buFont typeface="Arial" panose="020B0604020202020204" pitchFamily="34" charset="0"/>
-              <a:buChar char="•"/>
-            </a:pPr>
-            <a:r>
-              <a:rPr lang="ko-KR" altLang="en-US" dirty="0"/>
-              <a:t>**</a:t>
-            </a:r>
-            <a:r>
-              <a:rPr lang="en-US" altLang="ko-KR" dirty="0"/>
-              <a:t>App.js** </a:t>
-            </a:r>
-          </a:p>
-          <a:p>
-            <a:pPr marL="1143000" lvl="2" indent="-228600">
-              <a:buFont typeface="Arial" panose="020B0604020202020204" pitchFamily="34" charset="0"/>
-              <a:buChar char="•"/>
-            </a:pPr>
-            <a:r>
-              <a:rPr lang="ko-KR" altLang="en-US" dirty="0"/>
-              <a:t>기본으로 생성되는 </a:t>
-            </a:r>
-            <a:r>
-              <a:rPr lang="ko-KR" altLang="en-US" dirty="0" err="1"/>
-              <a:t>리액트</a:t>
-            </a:r>
-            <a:r>
-              <a:rPr lang="ko-KR" altLang="en-US" dirty="0"/>
-              <a:t> 컴포넌트</a:t>
-            </a:r>
-          </a:p>
         </p:txBody>
       </p:sp>
       <p:sp>
@@ -1703,7 +1958,7 @@
             <a:spLocks noGrp="1"/>
           </p:cNvSpPr>
           <p:nvPr>
-            <p:ph type="sldNum" sz="quarter" idx="5"/>
+            <p:ph type="sldNum" sz="quarter" idx="10"/>
           </p:nvPr>
         </p:nvSpPr>
         <p:spPr/>
@@ -1713,7 +1968,7 @@
           <a:p>
             <a:fld id="{C09E5BFC-1559-42F1-8940-AB342D56BF02}" type="slidenum">
               <a:rPr lang="ko-KR" altLang="en-US" smtClean="0"/>
-              <a:t>27</a:t>
+              <a:t>24</a:t>
             </a:fld>
             <a:endParaRPr lang="ko-KR" altLang="en-US"/>
           </a:p>
@@ -1722,7 +1977,252 @@
     </p:spTree>
     <p:extLst>
       <p:ext uri="{BB962C8B-B14F-4D97-AF65-F5344CB8AC3E}">
-        <p14:creationId xmlns:p14="http://schemas.microsoft.com/office/powerpoint/2010/main" val="4126840303"/>
+        <p14:creationId xmlns:p14="http://schemas.microsoft.com/office/powerpoint/2010/main" val="3875432298"/>
+      </p:ext>
+    </p:extLst>
+  </p:cSld>
+  <p:clrMapOvr>
+    <a:masterClrMapping/>
+  </p:clrMapOvr>
+</p:notes>
+</file>
+
+<file path=ppt/notesSlides/notesSlide19.xml><?xml version="1.0" encoding="utf-8"?>
+<p:notes xmlns:a="http://schemas.openxmlformats.org/drawingml/2006/main" xmlns:r="http://schemas.openxmlformats.org/officeDocument/2006/relationships" xmlns:p="http://schemas.openxmlformats.org/presentationml/2006/main">
+  <p:cSld>
+    <p:spTree>
+      <p:nvGrpSpPr>
+        <p:cNvPr id="1" name=""/>
+        <p:cNvGrpSpPr/>
+        <p:nvPr/>
+      </p:nvGrpSpPr>
+      <p:grpSpPr>
+        <a:xfrm>
+          <a:off x="0" y="0"/>
+          <a:ext cx="0" cy="0"/>
+          <a:chOff x="0" y="0"/>
+          <a:chExt cx="0" cy="0"/>
+        </a:xfrm>
+      </p:grpSpPr>
+      <p:sp>
+        <p:nvSpPr>
+          <p:cNvPr id="2" name="슬라이드 이미지 개체 틀 1"/>
+          <p:cNvSpPr>
+            <a:spLocks noGrp="1" noRot="1" noChangeAspect="1"/>
+          </p:cNvSpPr>
+          <p:nvPr>
+            <p:ph type="sldImg"/>
+          </p:nvPr>
+        </p:nvSpPr>
+        <p:spPr/>
+      </p:sp>
+      <p:sp>
+        <p:nvSpPr>
+          <p:cNvPr id="3" name="슬라이드 노트 개체 틀 2"/>
+          <p:cNvSpPr>
+            <a:spLocks noGrp="1"/>
+          </p:cNvSpPr>
+          <p:nvPr>
+            <p:ph type="body" idx="1"/>
+          </p:nvPr>
+        </p:nvSpPr>
+        <p:spPr/>
+        <p:txBody>
+          <a:bodyPr/>
+          <a:lstStyle/>
+          <a:p>
+            <a:r>
+              <a:rPr lang="en-US" altLang="ko-KR" dirty="0" err="1"/>
+              <a:t>npx</a:t>
+            </a:r>
+            <a:r>
+              <a:rPr lang="en-US" altLang="ko-KR" dirty="0"/>
+              <a:t> </a:t>
+            </a:r>
+            <a:r>
+              <a:rPr lang="ko-KR" altLang="en-US" dirty="0"/>
+              <a:t>변경사항이</a:t>
+            </a:r>
+            <a:r>
+              <a:rPr lang="ko-KR" altLang="en-US" baseline="0" dirty="0"/>
+              <a:t> 잦은 모듈을 사용할 때</a:t>
+            </a:r>
+            <a:r>
+              <a:rPr lang="en-US" altLang="ko-KR" baseline="0" dirty="0"/>
+              <a:t>, </a:t>
+            </a:r>
+            <a:r>
+              <a:rPr lang="ko-KR" altLang="en-US" baseline="0" dirty="0"/>
+              <a:t>매번 최신 버전을 설치하지 않도록 모듈을 로컬에 저장하지 않고 매번 최신 버전의 파일만을 불러와 실행시키는 방식</a:t>
+            </a:r>
+            <a:r>
+              <a:rPr lang="en-US" altLang="ko-KR" baseline="0" dirty="0"/>
+              <a:t>. </a:t>
+            </a:r>
+            <a:r>
+              <a:rPr lang="ko-KR" altLang="en-US" baseline="0" dirty="0"/>
+              <a:t>원래 </a:t>
+            </a:r>
+            <a:r>
+              <a:rPr lang="en-US" altLang="ko-KR" baseline="0" dirty="0" err="1"/>
+              <a:t>npm</a:t>
+            </a:r>
+            <a:r>
+              <a:rPr lang="ko-KR" altLang="en-US" baseline="0" dirty="0"/>
+              <a:t>으로 설치 후에 </a:t>
+            </a:r>
+            <a:r>
+              <a:rPr lang="ko-KR" altLang="en-US" baseline="0" dirty="0" err="1"/>
+              <a:t>사용해야하지만</a:t>
+            </a:r>
+            <a:r>
+              <a:rPr lang="ko-KR" altLang="en-US" baseline="0" dirty="0"/>
+              <a:t> </a:t>
+            </a:r>
+            <a:r>
+              <a:rPr lang="en-US" altLang="ko-KR" baseline="0" dirty="0" err="1"/>
+              <a:t>npm</a:t>
+            </a:r>
+            <a:r>
+              <a:rPr lang="en-US" altLang="ko-KR" baseline="0" dirty="0"/>
+              <a:t> 5.2.0 </a:t>
+            </a:r>
+            <a:r>
+              <a:rPr lang="ko-KR" altLang="en-US" baseline="0" dirty="0"/>
+              <a:t>버전부터 추가된 패키지 사용 도구</a:t>
+            </a:r>
+            <a:endParaRPr lang="en-US" altLang="ko-KR" baseline="0" dirty="0"/>
+          </a:p>
+          <a:p>
+            <a:endParaRPr lang="en-US" altLang="ko-KR" baseline="0" dirty="0"/>
+          </a:p>
+          <a:p>
+            <a:r>
+              <a:rPr lang="en-US" altLang="ko-KR" baseline="0" dirty="0"/>
+              <a:t>yarn: </a:t>
+            </a:r>
+            <a:r>
+              <a:rPr lang="en-US" altLang="ko-KR" baseline="0" dirty="0" err="1"/>
+              <a:t>npm</a:t>
+            </a:r>
+            <a:r>
+              <a:rPr lang="en-US" altLang="ko-KR" baseline="0" dirty="0"/>
+              <a:t> </a:t>
+            </a:r>
+            <a:r>
+              <a:rPr lang="ko-KR" altLang="en-US" baseline="0" dirty="0"/>
+              <a:t>처럼 사용하는 </a:t>
+            </a:r>
+            <a:r>
+              <a:rPr lang="en-US" altLang="ko-KR" baseline="0" dirty="0" err="1"/>
+              <a:t>facebook</a:t>
+            </a:r>
+            <a:r>
+              <a:rPr lang="en-US" altLang="ko-KR" baseline="0" dirty="0"/>
+              <a:t> </a:t>
+            </a:r>
+            <a:r>
+              <a:rPr lang="ko-KR" altLang="en-US" baseline="0" dirty="0"/>
+              <a:t>에서 만든 자바스크립트 패키지 매니저</a:t>
+            </a:r>
+            <a:r>
+              <a:rPr lang="en-US" altLang="ko-KR" baseline="0" dirty="0"/>
+              <a:t>, </a:t>
+            </a:r>
+            <a:r>
+              <a:rPr lang="en-US" altLang="ko-KR" baseline="0" dirty="0" err="1"/>
+              <a:t>npm</a:t>
+            </a:r>
+            <a:r>
+              <a:rPr lang="ko-KR" altLang="en-US" baseline="0" dirty="0"/>
+              <a:t>보다 빠르고 효율적임</a:t>
+            </a:r>
+            <a:r>
+              <a:rPr lang="en-US" altLang="ko-KR" baseline="0" dirty="0"/>
+              <a:t>. </a:t>
+            </a:r>
+            <a:r>
+              <a:rPr lang="ko-KR" altLang="en-US" baseline="0" dirty="0"/>
+              <a:t>하지만 </a:t>
+            </a:r>
+            <a:r>
+              <a:rPr lang="en-US" altLang="ko-KR" baseline="0" dirty="0" err="1"/>
+              <a:t>npm</a:t>
+            </a:r>
+            <a:r>
+              <a:rPr lang="ko-KR" altLang="en-US" baseline="0" dirty="0"/>
+              <a:t>이 기본이기 때문에 일단은 계속 </a:t>
+            </a:r>
+            <a:r>
+              <a:rPr lang="en-US" altLang="ko-KR" baseline="0" dirty="0" err="1"/>
+              <a:t>npm</a:t>
+            </a:r>
+            <a:r>
+              <a:rPr lang="ko-KR" altLang="en-US" baseline="0" dirty="0"/>
+              <a:t>으로 사용할 예정</a:t>
+            </a:r>
+            <a:r>
+              <a:rPr lang="en-US" altLang="ko-KR" baseline="0" dirty="0"/>
+              <a:t>. </a:t>
+            </a:r>
+            <a:r>
+              <a:rPr lang="ko-KR" altLang="en-US" baseline="0" dirty="0"/>
+              <a:t>나중에 공부하다가 </a:t>
+            </a:r>
+            <a:r>
+              <a:rPr lang="en-US" altLang="ko-KR" baseline="0" dirty="0"/>
+              <a:t>yarn</a:t>
+            </a:r>
+            <a:r>
+              <a:rPr lang="ko-KR" altLang="en-US" baseline="0" dirty="0"/>
+              <a:t>을 만나면 당황하지 말고 </a:t>
+            </a:r>
+            <a:r>
+              <a:rPr lang="en-US" altLang="ko-KR" baseline="0" dirty="0" err="1"/>
+              <a:t>npm</a:t>
+            </a:r>
+            <a:r>
+              <a:rPr lang="en-US" altLang="ko-KR" baseline="0" dirty="0"/>
+              <a:t> </a:t>
+            </a:r>
+            <a:r>
+              <a:rPr lang="ko-KR" altLang="en-US" baseline="0" dirty="0"/>
+              <a:t>처럼 쓰이는 친구라고 생각하면 됨</a:t>
+            </a:r>
+            <a:endParaRPr lang="ko-KR" altLang="en-US" dirty="0"/>
+          </a:p>
+          <a:p>
+            <a:endParaRPr lang="ko-KR" altLang="en-US" dirty="0"/>
+          </a:p>
+        </p:txBody>
+      </p:sp>
+      <p:sp>
+        <p:nvSpPr>
+          <p:cNvPr id="4" name="슬라이드 번호 개체 틀 3"/>
+          <p:cNvSpPr>
+            <a:spLocks noGrp="1"/>
+          </p:cNvSpPr>
+          <p:nvPr>
+            <p:ph type="sldNum" sz="quarter" idx="10"/>
+          </p:nvPr>
+        </p:nvSpPr>
+        <p:spPr/>
+        <p:txBody>
+          <a:bodyPr/>
+          <a:lstStyle/>
+          <a:p>
+            <a:fld id="{C09E5BFC-1559-42F1-8940-AB342D56BF02}" type="slidenum">
+              <a:rPr lang="ko-KR" altLang="en-US" smtClean="0"/>
+              <a:t>25</a:t>
+            </a:fld>
+            <a:endParaRPr lang="ko-KR" altLang="en-US"/>
+          </a:p>
+        </p:txBody>
+      </p:sp>
+    </p:spTree>
+    <p:extLst>
+      <p:ext uri="{BB962C8B-B14F-4D97-AF65-F5344CB8AC3E}">
+        <p14:creationId xmlns:p14="http://schemas.microsoft.com/office/powerpoint/2010/main" val="3910243359"/>
       </p:ext>
     </p:extLst>
   </p:cSld>
@@ -1856,6 +2356,412 @@
     <p:extLst>
       <p:ext uri="{BB962C8B-B14F-4D97-AF65-F5344CB8AC3E}">
         <p14:creationId xmlns:p14="http://schemas.microsoft.com/office/powerpoint/2010/main" val="453950005"/>
+      </p:ext>
+    </p:extLst>
+  </p:cSld>
+  <p:clrMapOvr>
+    <a:masterClrMapping/>
+  </p:clrMapOvr>
+</p:notes>
+</file>
+
+<file path=ppt/notesSlides/notesSlide20.xml><?xml version="1.0" encoding="utf-8"?>
+<p:notes xmlns:a="http://schemas.openxmlformats.org/drawingml/2006/main" xmlns:r="http://schemas.openxmlformats.org/officeDocument/2006/relationships" xmlns:p="http://schemas.openxmlformats.org/presentationml/2006/main">
+  <p:cSld>
+    <p:spTree>
+      <p:nvGrpSpPr>
+        <p:cNvPr id="1" name=""/>
+        <p:cNvGrpSpPr/>
+        <p:nvPr/>
+      </p:nvGrpSpPr>
+      <p:grpSpPr>
+        <a:xfrm>
+          <a:off x="0" y="0"/>
+          <a:ext cx="0" cy="0"/>
+          <a:chOff x="0" y="0"/>
+          <a:chExt cx="0" cy="0"/>
+        </a:xfrm>
+      </p:grpSpPr>
+      <p:sp>
+        <p:nvSpPr>
+          <p:cNvPr id="2" name="슬라이드 이미지 개체 틀 1"/>
+          <p:cNvSpPr>
+            <a:spLocks noGrp="1" noRot="1" noChangeAspect="1"/>
+          </p:cNvSpPr>
+          <p:nvPr>
+            <p:ph type="sldImg"/>
+          </p:nvPr>
+        </p:nvSpPr>
+        <p:spPr/>
+      </p:sp>
+      <p:sp>
+        <p:nvSpPr>
+          <p:cNvPr id="3" name="슬라이드 노트 개체 틀 2"/>
+          <p:cNvSpPr>
+            <a:spLocks noGrp="1"/>
+          </p:cNvSpPr>
+          <p:nvPr>
+            <p:ph type="body" idx="1"/>
+          </p:nvPr>
+        </p:nvSpPr>
+        <p:spPr/>
+        <p:txBody>
+          <a:bodyPr/>
+          <a:lstStyle/>
+          <a:p>
+            <a:endParaRPr lang="ko-KR" altLang="en-US" dirty="0"/>
+          </a:p>
+        </p:txBody>
+      </p:sp>
+      <p:sp>
+        <p:nvSpPr>
+          <p:cNvPr id="4" name="슬라이드 번호 개체 틀 3"/>
+          <p:cNvSpPr>
+            <a:spLocks noGrp="1"/>
+          </p:cNvSpPr>
+          <p:nvPr>
+            <p:ph type="sldNum" sz="quarter" idx="5"/>
+          </p:nvPr>
+        </p:nvSpPr>
+        <p:spPr/>
+        <p:txBody>
+          <a:bodyPr/>
+          <a:lstStyle/>
+          <a:p>
+            <a:fld id="{C09E5BFC-1559-42F1-8940-AB342D56BF02}" type="slidenum">
+              <a:rPr lang="ko-KR" altLang="en-US" smtClean="0"/>
+              <a:t>26</a:t>
+            </a:fld>
+            <a:endParaRPr lang="ko-KR" altLang="en-US"/>
+          </a:p>
+        </p:txBody>
+      </p:sp>
+    </p:spTree>
+    <p:extLst>
+      <p:ext uri="{BB962C8B-B14F-4D97-AF65-F5344CB8AC3E}">
+        <p14:creationId xmlns:p14="http://schemas.microsoft.com/office/powerpoint/2010/main" val="1615425653"/>
+      </p:ext>
+    </p:extLst>
+  </p:cSld>
+  <p:clrMapOvr>
+    <a:masterClrMapping/>
+  </p:clrMapOvr>
+</p:notes>
+</file>
+
+<file path=ppt/notesSlides/notesSlide21.xml><?xml version="1.0" encoding="utf-8"?>
+<p:notes xmlns:a="http://schemas.openxmlformats.org/drawingml/2006/main" xmlns:r="http://schemas.openxmlformats.org/officeDocument/2006/relationships" xmlns:p="http://schemas.openxmlformats.org/presentationml/2006/main">
+  <p:cSld>
+    <p:spTree>
+      <p:nvGrpSpPr>
+        <p:cNvPr id="1" name=""/>
+        <p:cNvGrpSpPr/>
+        <p:nvPr/>
+      </p:nvGrpSpPr>
+      <p:grpSpPr>
+        <a:xfrm>
+          <a:off x="0" y="0"/>
+          <a:ext cx="0" cy="0"/>
+          <a:chOff x="0" y="0"/>
+          <a:chExt cx="0" cy="0"/>
+        </a:xfrm>
+      </p:grpSpPr>
+      <p:sp>
+        <p:nvSpPr>
+          <p:cNvPr id="2" name="슬라이드 이미지 개체 틀 1"/>
+          <p:cNvSpPr>
+            <a:spLocks noGrp="1" noRot="1" noChangeAspect="1"/>
+          </p:cNvSpPr>
+          <p:nvPr>
+            <p:ph type="sldImg"/>
+          </p:nvPr>
+        </p:nvSpPr>
+        <p:spPr/>
+      </p:sp>
+      <p:sp>
+        <p:nvSpPr>
+          <p:cNvPr id="3" name="슬라이드 노트 개체 틀 2"/>
+          <p:cNvSpPr>
+            <a:spLocks noGrp="1"/>
+          </p:cNvSpPr>
+          <p:nvPr>
+            <p:ph type="body" idx="1"/>
+          </p:nvPr>
+        </p:nvSpPr>
+        <p:spPr/>
+        <p:txBody>
+          <a:bodyPr/>
+          <a:lstStyle/>
+          <a:p>
+            <a:pPr>
+              <a:buFont typeface="Arial" panose="020B0604020202020204" pitchFamily="34" charset="0"/>
+              <a:buChar char="•"/>
+            </a:pPr>
+            <a:r>
+              <a:rPr lang="ko-KR" altLang="en-US" dirty="0"/>
+              <a:t>**</a:t>
+            </a:r>
+            <a:r>
+              <a:rPr lang="en-US" altLang="ko-KR" dirty="0" err="1"/>
+              <a:t>package.json</a:t>
+            </a:r>
+            <a:r>
+              <a:rPr lang="en-US" altLang="ko-KR" dirty="0"/>
+              <a:t>** </a:t>
+            </a:r>
+          </a:p>
+          <a:p>
+            <a:pPr marL="742950" lvl="1" indent="-285750">
+              <a:buFont typeface="Arial" panose="020B0604020202020204" pitchFamily="34" charset="0"/>
+              <a:buChar char="•"/>
+            </a:pPr>
+            <a:r>
+              <a:rPr lang="ko-KR" altLang="en-US" dirty="0"/>
+              <a:t>이 프로젝트의 메타 데이터</a:t>
+            </a:r>
+          </a:p>
+          <a:p>
+            <a:pPr marL="742950" lvl="1" indent="-285750">
+              <a:buFont typeface="Arial" panose="020B0604020202020204" pitchFamily="34" charset="0"/>
+              <a:buChar char="•"/>
+            </a:pPr>
+            <a:r>
+              <a:rPr lang="ko-KR" altLang="en-US" dirty="0"/>
+              <a:t>사용할 </a:t>
+            </a:r>
+            <a:r>
+              <a:rPr lang="en-US" altLang="ko-KR" dirty="0"/>
+              <a:t>node.js </a:t>
+            </a:r>
+            <a:r>
+              <a:rPr lang="ko-KR" altLang="en-US" dirty="0"/>
+              <a:t>패키지 목록 등을 </a:t>
+            </a:r>
+            <a:r>
+              <a:rPr lang="ko-KR" altLang="en-US" dirty="0" err="1"/>
+              <a:t>퐇마</a:t>
+            </a:r>
+            <a:endParaRPr lang="ko-KR" altLang="en-US" dirty="0"/>
+          </a:p>
+          <a:p>
+            <a:pPr>
+              <a:buFont typeface="Arial" panose="020B0604020202020204" pitchFamily="34" charset="0"/>
+              <a:buChar char="•"/>
+            </a:pPr>
+            <a:r>
+              <a:rPr lang="ko-KR" altLang="en-US" dirty="0"/>
+              <a:t>**</a:t>
+            </a:r>
+            <a:r>
+              <a:rPr lang="en-US" altLang="ko-KR" dirty="0"/>
+              <a:t>public/** </a:t>
+            </a:r>
+          </a:p>
+          <a:p>
+            <a:pPr marL="742950" lvl="1" indent="-285750">
+              <a:buFont typeface="Arial" panose="020B0604020202020204" pitchFamily="34" charset="0"/>
+              <a:buChar char="•"/>
+            </a:pPr>
+            <a:r>
+              <a:rPr lang="en-US" altLang="ko-KR" b="1" dirty="0"/>
+              <a:t>index.html</a:t>
+            </a:r>
+            <a:r>
+              <a:rPr lang="en-US" altLang="ko-KR" dirty="0"/>
+              <a:t>: </a:t>
+            </a:r>
+            <a:r>
+              <a:rPr lang="en-US" altLang="ko-KR" dirty="0">
+                <a:hlinkClick r:id="rId3"/>
+              </a:rPr>
+              <a:t>http://localhost:3000</a:t>
+            </a:r>
+            <a:r>
+              <a:rPr lang="ko-KR" altLang="en-US" dirty="0"/>
+              <a:t> 이 가장 먼저 </a:t>
+            </a:r>
+            <a:r>
+              <a:rPr lang="ko-KR" altLang="en-US" dirty="0" err="1"/>
+              <a:t>리턴하는</a:t>
+            </a:r>
+            <a:r>
+              <a:rPr lang="ko-KR" altLang="en-US" dirty="0"/>
+              <a:t> 파일 </a:t>
+            </a:r>
+          </a:p>
+          <a:p>
+            <a:pPr marL="1143000" lvl="2" indent="-228600">
+              <a:buFont typeface="Arial" panose="020B0604020202020204" pitchFamily="34" charset="0"/>
+              <a:buChar char="•"/>
+            </a:pPr>
+            <a:r>
+              <a:rPr lang="ko-KR" altLang="en-US" dirty="0"/>
+              <a:t>현재 유일한 </a:t>
+            </a:r>
+            <a:r>
+              <a:rPr lang="en-US" altLang="ko-KR" dirty="0"/>
+              <a:t>html </a:t>
+            </a:r>
+            <a:r>
+              <a:rPr lang="ko-KR" altLang="en-US" dirty="0"/>
+              <a:t>파일</a:t>
+            </a:r>
+          </a:p>
+          <a:p>
+            <a:pPr marL="742950" lvl="1" indent="-285750">
+              <a:buFont typeface="Arial" panose="020B0604020202020204" pitchFamily="34" charset="0"/>
+              <a:buChar char="•"/>
+            </a:pPr>
+            <a:r>
+              <a:rPr lang="ko-KR" altLang="en-US" dirty="0"/>
+              <a:t>다른 페이지들은 </a:t>
+            </a:r>
+            <a:r>
+              <a:rPr lang="en-US" altLang="ko-KR" dirty="0"/>
+              <a:t>React.js</a:t>
+            </a:r>
+            <a:r>
+              <a:rPr lang="ko-KR" altLang="en-US" dirty="0"/>
+              <a:t>를 통해 생성되어 </a:t>
+            </a:r>
+            <a:r>
+              <a:rPr lang="en-US" altLang="ko-KR" dirty="0"/>
+              <a:t>&lt;div id="root"&gt; </a:t>
+            </a:r>
+            <a:r>
+              <a:rPr lang="ko-KR" altLang="en-US" dirty="0"/>
+              <a:t>요소 아래에 동적으로 렌더링 됨</a:t>
+            </a:r>
+          </a:p>
+          <a:p>
+            <a:pPr>
+              <a:buFont typeface="Arial" panose="020B0604020202020204" pitchFamily="34" charset="0"/>
+              <a:buChar char="•"/>
+            </a:pPr>
+            <a:r>
+              <a:rPr lang="ko-KR" altLang="en-US" dirty="0"/>
+              <a:t>**</a:t>
+            </a:r>
+            <a:r>
+              <a:rPr lang="en-US" altLang="ko-KR" dirty="0" err="1"/>
+              <a:t>src</a:t>
+            </a:r>
+            <a:r>
+              <a:rPr lang="en-US" altLang="ko-KR" dirty="0"/>
+              <a:t>/** </a:t>
+            </a:r>
+          </a:p>
+          <a:p>
+            <a:pPr marL="742950" lvl="1" indent="-285750">
+              <a:buFont typeface="Arial" panose="020B0604020202020204" pitchFamily="34" charset="0"/>
+              <a:buChar char="•"/>
+            </a:pPr>
+            <a:r>
+              <a:rPr lang="en-US" altLang="ko-KR" dirty="0"/>
+              <a:t>**index.js** </a:t>
+            </a:r>
+          </a:p>
+          <a:p>
+            <a:pPr marL="1143000" lvl="2" indent="-228600">
+              <a:buFont typeface="Arial" panose="020B0604020202020204" pitchFamily="34" charset="0"/>
+              <a:buChar char="•"/>
+            </a:pPr>
+            <a:r>
+              <a:rPr lang="en-US" altLang="ko-KR" dirty="0"/>
+              <a:t>index.html</a:t>
+            </a:r>
+            <a:r>
+              <a:rPr lang="ko-KR" altLang="en-US" dirty="0"/>
+              <a:t>과 함께 가장 처음으로 실행 되는 자바스크립트 코드</a:t>
+            </a:r>
+          </a:p>
+          <a:p>
+            <a:pPr marL="1143000" lvl="2" indent="-228600">
+              <a:buFont typeface="Arial" panose="020B0604020202020204" pitchFamily="34" charset="0"/>
+              <a:buChar char="•"/>
+            </a:pPr>
+            <a:r>
+              <a:rPr lang="ko-KR" altLang="en-US" dirty="0"/>
+              <a:t>이 자바스크립트 코드가 </a:t>
+            </a:r>
+            <a:r>
+              <a:rPr lang="ko-KR" altLang="en-US" dirty="0" err="1"/>
+              <a:t>리액트</a:t>
+            </a:r>
+            <a:r>
+              <a:rPr lang="ko-KR" altLang="en-US" dirty="0"/>
+              <a:t> 컴포넌트를 </a:t>
+            </a:r>
+            <a:r>
+              <a:rPr lang="en-US" altLang="ko-KR" dirty="0"/>
+              <a:t>root </a:t>
+            </a:r>
+            <a:r>
+              <a:rPr lang="ko-KR" altLang="en-US" dirty="0"/>
+              <a:t>아래에 추가</a:t>
+            </a:r>
+          </a:p>
+          <a:p>
+            <a:pPr marL="742950" lvl="1" indent="-285750">
+              <a:buFont typeface="Arial" panose="020B0604020202020204" pitchFamily="34" charset="0"/>
+              <a:buChar char="•"/>
+            </a:pPr>
+            <a:r>
+              <a:rPr lang="ko-KR" altLang="en-US" dirty="0"/>
+              <a:t>**</a:t>
+            </a:r>
+            <a:r>
+              <a:rPr lang="en-US" altLang="ko-KR" dirty="0"/>
+              <a:t>App.js** </a:t>
+            </a:r>
+          </a:p>
+          <a:p>
+            <a:pPr marL="1143000" lvl="2" indent="-228600">
+              <a:buFont typeface="Arial" panose="020B0604020202020204" pitchFamily="34" charset="0"/>
+              <a:buChar char="•"/>
+            </a:pPr>
+            <a:r>
+              <a:rPr lang="ko-KR" altLang="en-US" dirty="0"/>
+              <a:t>기본으로 생성되는 </a:t>
+            </a:r>
+            <a:r>
+              <a:rPr lang="ko-KR" altLang="en-US" dirty="0" err="1"/>
+              <a:t>리액트</a:t>
+            </a:r>
+            <a:r>
+              <a:rPr lang="ko-KR" altLang="en-US" dirty="0"/>
+              <a:t> 컴포넌트</a:t>
+            </a:r>
+          </a:p>
+        </p:txBody>
+      </p:sp>
+      <p:sp>
+        <p:nvSpPr>
+          <p:cNvPr id="4" name="슬라이드 번호 개체 틀 3"/>
+          <p:cNvSpPr>
+            <a:spLocks noGrp="1"/>
+          </p:cNvSpPr>
+          <p:nvPr>
+            <p:ph type="sldNum" sz="quarter" idx="5"/>
+          </p:nvPr>
+        </p:nvSpPr>
+        <p:spPr/>
+        <p:txBody>
+          <a:bodyPr/>
+          <a:lstStyle/>
+          <a:p>
+            <a:fld id="{C09E5BFC-1559-42F1-8940-AB342D56BF02}" type="slidenum">
+              <a:rPr lang="ko-KR" altLang="en-US" smtClean="0"/>
+              <a:t>27</a:t>
+            </a:fld>
+            <a:endParaRPr lang="ko-KR" altLang="en-US"/>
+          </a:p>
+        </p:txBody>
+      </p:sp>
+    </p:spTree>
+    <p:extLst>
+      <p:ext uri="{BB962C8B-B14F-4D97-AF65-F5344CB8AC3E}">
+        <p14:creationId xmlns:p14="http://schemas.microsoft.com/office/powerpoint/2010/main" val="4126840303"/>
       </p:ext>
     </p:extLst>
   </p:cSld>
@@ -2704,6 +3610,151 @@
             <a:r>
               <a:rPr lang="ko-KR" altLang="en-US" dirty="0"/>
               <a:t>자식</a:t>
+            </a:r>
+            <a:r>
+              <a:rPr lang="en-US" altLang="ko-KR" dirty="0"/>
+              <a:t> – </a:t>
+            </a:r>
+            <a:r>
+              <a:rPr lang="ko-KR" altLang="en-US" dirty="0"/>
+              <a:t>한 방향으로만 흐르는 방식</a:t>
+            </a:r>
+            <a:endParaRPr lang="en-US" altLang="ko-KR" dirty="0"/>
+          </a:p>
+          <a:p>
+            <a:r>
+              <a:rPr lang="ko-KR" altLang="en-US" dirty="0"/>
+              <a:t>데이터가 부모에서 자식으로 흐른다</a:t>
+            </a:r>
+            <a:r>
+              <a:rPr lang="en-US" altLang="ko-KR" dirty="0"/>
+              <a:t>.</a:t>
+            </a:r>
+          </a:p>
+          <a:p>
+            <a:pPr marL="171450" indent="-171450">
+              <a:buFontTx/>
+              <a:buChar char="-"/>
+            </a:pPr>
+            <a:r>
+              <a:rPr lang="ko-KR" altLang="en-US" dirty="0"/>
+              <a:t>애플리케이션의 상태와 데이터 흐름으로 인해 상태 변화가 어떻게 발생하는지 더욱 예측 가능하고 관리하기 쉽게 만든다</a:t>
+            </a:r>
+            <a:r>
+              <a:rPr lang="en-US" altLang="ko-KR" dirty="0"/>
+              <a:t>.</a:t>
+            </a:r>
+          </a:p>
+          <a:p>
+            <a:pPr marL="171450" indent="-171450">
+              <a:buFontTx/>
+              <a:buChar char="-"/>
+            </a:pPr>
+            <a:endParaRPr lang="en-US" altLang="ko-KR" dirty="0"/>
+          </a:p>
+          <a:p>
+            <a:pPr marL="171450" indent="-171450">
+              <a:buFontTx/>
+              <a:buChar char="-"/>
+            </a:pPr>
+            <a:r>
+              <a:rPr lang="en-US" altLang="ko-KR" dirty="0"/>
+              <a:t>1. </a:t>
+            </a:r>
+            <a:r>
+              <a:rPr lang="ko-KR" altLang="en-US" dirty="0"/>
+              <a:t>부모에서 자식으로 </a:t>
+            </a:r>
+            <a:r>
+              <a:rPr lang="en-US" altLang="ko-KR" dirty="0"/>
+              <a:t>(Top –down)</a:t>
+            </a:r>
+          </a:p>
+          <a:p>
+            <a:pPr marL="171450" indent="-171450">
+              <a:buFont typeface="Wingdings" panose="05000000000000000000" pitchFamily="2" charset="2"/>
+              <a:buChar char="n"/>
+            </a:pPr>
+            <a:r>
+              <a:rPr lang="ko-KR" altLang="en-US" dirty="0"/>
+              <a:t>자식 컴포넌트는 </a:t>
+            </a:r>
+            <a:r>
+              <a:rPr lang="en-US" altLang="ko-KR" dirty="0"/>
+              <a:t>props</a:t>
+            </a:r>
+            <a:r>
+              <a:rPr lang="ko-KR" altLang="en-US" dirty="0"/>
+              <a:t>를 통해 데이터를 받는다</a:t>
+            </a:r>
+            <a:r>
+              <a:rPr lang="en-US" altLang="ko-KR" dirty="0"/>
+              <a:t>.</a:t>
+            </a:r>
+          </a:p>
+          <a:p>
+            <a:pPr marL="171450" indent="-171450">
+              <a:buFont typeface="Wingdings" panose="05000000000000000000" pitchFamily="2" charset="2"/>
+              <a:buChar char="n"/>
+            </a:pPr>
+            <a:endParaRPr lang="en-US" altLang="ko-KR" dirty="0"/>
+          </a:p>
+          <a:p>
+            <a:pPr marL="171450" indent="-171450">
+              <a:buFontTx/>
+              <a:buChar char="-"/>
+            </a:pPr>
+            <a:r>
+              <a:rPr lang="en-US" altLang="ko-KR" dirty="0"/>
+              <a:t>2. </a:t>
+            </a:r>
+            <a:r>
+              <a:rPr lang="ko-KR" altLang="en-US" dirty="0"/>
+              <a:t>불변성</a:t>
+            </a:r>
+            <a:endParaRPr lang="en-US" altLang="ko-KR" dirty="0"/>
+          </a:p>
+          <a:p>
+            <a:pPr marL="171450" indent="-171450">
+              <a:buFont typeface="Wingdings" panose="05000000000000000000" pitchFamily="2" charset="2"/>
+              <a:buChar char="n"/>
+            </a:pPr>
+            <a:r>
+              <a:rPr lang="en-US" altLang="ko-KR" dirty="0"/>
+              <a:t>Props </a:t>
+            </a:r>
+            <a:r>
+              <a:rPr lang="ko-KR" altLang="en-US" dirty="0"/>
+              <a:t>는 읽기전용</a:t>
+            </a:r>
+            <a:r>
+              <a:rPr lang="en-US" altLang="ko-KR" dirty="0"/>
+              <a:t>. </a:t>
+            </a:r>
+            <a:r>
+              <a:rPr lang="ko-KR" altLang="en-US" dirty="0"/>
+              <a:t>변경 </a:t>
+            </a:r>
+            <a:r>
+              <a:rPr lang="en-US" altLang="ko-KR" dirty="0"/>
+              <a:t>x</a:t>
+            </a:r>
+          </a:p>
+          <a:p>
+            <a:pPr marL="0" indent="0">
+              <a:buFont typeface="Wingdings" panose="05000000000000000000" pitchFamily="2" charset="2"/>
+              <a:buNone/>
+            </a:pPr>
+            <a:endParaRPr lang="en-US" altLang="ko-KR" dirty="0"/>
+          </a:p>
+          <a:p>
+            <a:pPr marL="0" indent="0">
+              <a:buFontTx/>
+              <a:buNone/>
+            </a:pPr>
+            <a:r>
+              <a:rPr lang="en-US" altLang="ko-KR" dirty="0"/>
+              <a:t> </a:t>
             </a:r>
           </a:p>
         </p:txBody>
@@ -7879,7 +8930,7 @@
           <p:nvPr/>
         </p:nvPicPr>
         <p:blipFill rotWithShape="1">
-          <a:blip r:embed="rId2"/>
+          <a:blip r:embed="rId3"/>
           <a:srcRect r="4136" b="6739"/>
           <a:stretch/>
         </p:blipFill>
@@ -8091,7 +9142,7 @@
           <p:nvPr/>
         </p:nvPicPr>
         <p:blipFill>
-          <a:blip r:embed="rId2">
+          <a:blip r:embed="rId3">
             <a:extLst>
               <a:ext uri="{28A0092B-C50C-407E-A947-70E740481C1C}">
                 <a14:useLocalDpi xmlns:a14="http://schemas.microsoft.com/office/drawing/2010/main" val="0"/>

</xml_diff>

<commit_message>
react 수업 준비 ppx (7/29)
</commit_message>
<xml_diff>
--- a/material/[SeSAC_YDP_6] 22_React_소개.pptx
+++ b/material/[SeSAC_YDP_6] 22_React_소개.pptx
@@ -226,7 +226,7 @@
           <a:p>
             <a:fld id="{2EF3F159-7250-4DD4-91C2-13B35D56E1AF}" type="datetimeFigureOut">
               <a:rPr lang="ko-KR" altLang="en-US" smtClean="0"/>
-              <a:t>2024-07-23</a:t>
+              <a:t>2024-07-28</a:t>
             </a:fld>
             <a:endParaRPr lang="ko-KR" altLang="en-US"/>
           </a:p>
@@ -2282,14 +2282,49 @@
               <a:t>주로 최신 문법과 기능을 지원하지 않는 환경에서도 코드를 실행할 수 있게 해준다</a:t>
             </a:r>
             <a:r>
-              <a:rPr lang="en-US" altLang="ko-KR" dirty="0"/>
+              <a:rPr lang="en-US" altLang="ko-KR" dirty="0" smtClean="0"/>
               <a:t>.</a:t>
             </a:r>
           </a:p>
           <a:p>
+            <a:r>
+              <a:rPr lang="en-US" altLang="ko-KR" dirty="0" smtClean="0"/>
+              <a:t>(</a:t>
+            </a:r>
+            <a:r>
+              <a:rPr lang="ko-KR" altLang="en-US" dirty="0" smtClean="0"/>
+              <a:t>화살표 함수</a:t>
+            </a:r>
+            <a:r>
+              <a:rPr lang="en-US" altLang="ko-KR" dirty="0" smtClean="0"/>
+              <a:t>, </a:t>
+            </a:r>
+            <a:r>
+              <a:rPr lang="en-US" altLang="ko-KR" dirty="0" err="1" smtClean="0"/>
+              <a:t>async</a:t>
+            </a:r>
+            <a:r>
+              <a:rPr lang="en-US" altLang="ko-KR" dirty="0" smtClean="0"/>
+              <a:t>/await</a:t>
+            </a:r>
+            <a:r>
+              <a:rPr lang="en-US" altLang="ko-KR" baseline="0" dirty="0" smtClean="0"/>
+              <a:t> </a:t>
+            </a:r>
+            <a:r>
+              <a:rPr lang="ko-KR" altLang="en-US" baseline="0" dirty="0" smtClean="0"/>
+              <a:t>등</a:t>
+            </a:r>
+            <a:r>
+              <a:rPr lang="en-US" altLang="ko-KR" baseline="0" dirty="0" smtClean="0"/>
+              <a:t>)</a:t>
+            </a:r>
             <a:endParaRPr lang="en-US" altLang="ko-KR" dirty="0"/>
           </a:p>
           <a:p>
+            <a:endParaRPr lang="en-US" altLang="ko-KR" dirty="0"/>
+          </a:p>
+          <a:p>
             <a:r>
               <a:rPr lang="en-US" altLang="ko-KR" dirty="0"/>
               <a:t>*</a:t>
@@ -2369,16 +2404,40 @@
           </a:p>
           <a:p>
             <a:r>
-              <a:rPr lang="en-US" altLang="ko-KR" dirty="0"/>
-              <a:t>Babel</a:t>
-            </a:r>
-            <a:r>
-              <a:rPr lang="ko-KR" altLang="en-US" dirty="0"/>
-              <a:t>은 </a:t>
-            </a:r>
-            <a:r>
-              <a:rPr lang="ko-KR" altLang="en-US" dirty="0" err="1"/>
-              <a:t>ㅇㅈ</a:t>
+              <a:rPr lang="ko-KR" altLang="en-US" dirty="0" smtClean="0"/>
+              <a:t>즉</a:t>
+            </a:r>
+            <a:r>
+              <a:rPr lang="en-US" altLang="ko-KR" dirty="0" smtClean="0"/>
+              <a:t>, </a:t>
+            </a:r>
+            <a:r>
+              <a:rPr lang="en-US" altLang="ko-KR" dirty="0" err="1" smtClean="0"/>
+              <a:t>Bable</a:t>
+            </a:r>
+            <a:r>
+              <a:rPr lang="ko-KR" altLang="en-US" dirty="0" smtClean="0"/>
+              <a:t>을 사용하면 최신 </a:t>
+            </a:r>
+            <a:r>
+              <a:rPr lang="en-US" altLang="ko-KR" dirty="0" smtClean="0"/>
+              <a:t>JS</a:t>
+            </a:r>
+            <a:r>
+              <a:rPr lang="ko-KR" altLang="en-US" dirty="0" smtClean="0"/>
+              <a:t>문법을 마음껏 사용할 수 있고</a:t>
+            </a:r>
+            <a:r>
+              <a:rPr lang="en-US" altLang="ko-KR" dirty="0" smtClean="0"/>
+              <a:t>, </a:t>
+            </a:r>
+            <a:r>
+              <a:rPr lang="ko-KR" altLang="en-US" dirty="0" smtClean="0"/>
+              <a:t>호환성 문제를 걱정할 필요</a:t>
+            </a:r>
+            <a:r>
+              <a:rPr lang="en-US" altLang="ko-KR" dirty="0" smtClean="0"/>
+              <a:t>x</a:t>
             </a:r>
             <a:endParaRPr lang="ko-KR" altLang="en-US" dirty="0"/>
           </a:p>
@@ -2464,7 +2523,1459 @@
           <a:bodyPr/>
           <a:lstStyle/>
           <a:p>
-            <a:endParaRPr lang="ko-KR" altLang="en-US" dirty="0"/>
+            <a:r>
+              <a:rPr lang="en-US" altLang="ko-KR" dirty="0" smtClean="0"/>
+              <a:t>** </a:t>
+            </a:r>
+            <a:r>
+              <a:rPr lang="en-US" altLang="ko-KR" dirty="0" err="1" smtClean="0"/>
+              <a:t>Webpack</a:t>
+            </a:r>
+            <a:r>
+              <a:rPr lang="ko-KR" altLang="en-US" dirty="0" smtClean="0"/>
+              <a:t>은 주로 빌드 시스템으로 사용됨</a:t>
+            </a:r>
+            <a:r>
+              <a:rPr lang="en-US" altLang="ko-KR" dirty="0" smtClean="0"/>
+              <a:t>.</a:t>
+            </a:r>
+          </a:p>
+          <a:p>
+            <a:r>
+              <a:rPr lang="ko-KR" altLang="en-US" dirty="0" smtClean="0"/>
+              <a:t>여러가지 자원을 </a:t>
+            </a:r>
+            <a:r>
+              <a:rPr lang="ko-KR" altLang="en-US" dirty="0" err="1" smtClean="0"/>
+              <a:t>번들링하고</a:t>
+            </a:r>
+            <a:r>
+              <a:rPr lang="ko-KR" altLang="en-US" dirty="0" smtClean="0"/>
+              <a:t> 최적화하는 도구이다</a:t>
+            </a:r>
+            <a:r>
+              <a:rPr lang="en-US" altLang="ko-KR" dirty="0" smtClean="0"/>
+              <a:t>.</a:t>
+            </a:r>
+            <a:br>
+              <a:rPr lang="en-US" altLang="ko-KR" dirty="0" smtClean="0"/>
+            </a:br>
+            <a:r>
+              <a:rPr lang="en-US" altLang="ko-KR" dirty="0" smtClean="0"/>
+              <a:t/>
+            </a:r>
+            <a:br>
+              <a:rPr lang="en-US" altLang="ko-KR" dirty="0" smtClean="0"/>
+            </a:br>
+            <a:r>
+              <a:rPr lang="en-US" altLang="ko-KR" dirty="0" smtClean="0"/>
+              <a:t>** </a:t>
+            </a:r>
+            <a:r>
+              <a:rPr lang="ko-KR" altLang="en-US" dirty="0" err="1" smtClean="0"/>
+              <a:t>번들링</a:t>
+            </a:r>
+            <a:endParaRPr lang="en-US" altLang="ko-KR" dirty="0" smtClean="0"/>
+          </a:p>
+          <a:p>
+            <a:pPr marL="171450" indent="-171450">
+              <a:buFontTx/>
+              <a:buChar char="-"/>
+            </a:pPr>
+            <a:r>
+              <a:rPr lang="en-US" altLang="ko-KR" baseline="0" dirty="0" err="1" smtClean="0"/>
+              <a:t>Webpack</a:t>
+            </a:r>
+            <a:r>
+              <a:rPr lang="ko-KR" altLang="en-US" baseline="0" dirty="0" smtClean="0"/>
+              <a:t>은 여러 개의 </a:t>
+            </a:r>
+            <a:r>
+              <a:rPr lang="en-US" altLang="ko-KR" baseline="0" dirty="0" smtClean="0"/>
+              <a:t>JS </a:t>
+            </a:r>
+            <a:r>
+              <a:rPr lang="ko-KR" altLang="en-US" baseline="0" dirty="0" smtClean="0"/>
+              <a:t>파일 및 다양한 종류의 리소스 </a:t>
+            </a:r>
+            <a:r>
+              <a:rPr lang="en-US" altLang="ko-KR" baseline="0" dirty="0" smtClean="0"/>
+              <a:t>(</a:t>
+            </a:r>
+            <a:r>
+              <a:rPr lang="ko-KR" altLang="en-US" baseline="0" dirty="0" smtClean="0"/>
+              <a:t>이미지</a:t>
+            </a:r>
+            <a:r>
+              <a:rPr lang="en-US" altLang="ko-KR" baseline="0" dirty="0" smtClean="0"/>
+              <a:t>, </a:t>
+            </a:r>
+            <a:r>
+              <a:rPr lang="en-US" altLang="ko-KR" baseline="0" dirty="0" err="1" smtClean="0"/>
+              <a:t>css</a:t>
+            </a:r>
+            <a:r>
+              <a:rPr lang="en-US" altLang="ko-KR" baseline="0" dirty="0" smtClean="0"/>
+              <a:t> </a:t>
+            </a:r>
+            <a:r>
+              <a:rPr lang="ko-KR" altLang="en-US" baseline="0" dirty="0" smtClean="0"/>
+              <a:t>등</a:t>
+            </a:r>
+            <a:r>
+              <a:rPr lang="en-US" altLang="ko-KR" baseline="0" dirty="0" smtClean="0"/>
+              <a:t>)</a:t>
+            </a:r>
+            <a:r>
+              <a:rPr lang="ko-KR" altLang="en-US" baseline="0" dirty="0" smtClean="0"/>
+              <a:t>을 하나로 묶어주는 역할을 한다</a:t>
+            </a:r>
+            <a:r>
+              <a:rPr lang="en-US" altLang="ko-KR" baseline="0" dirty="0" smtClean="0"/>
+              <a:t>.</a:t>
+            </a:r>
+          </a:p>
+          <a:p>
+            <a:pPr marL="171450" indent="-171450">
+              <a:buFontTx/>
+              <a:buChar char="-"/>
+            </a:pPr>
+            <a:r>
+              <a:rPr lang="ko-KR" altLang="en-US" baseline="0" dirty="0" smtClean="0"/>
+              <a:t>이 과정을 </a:t>
+            </a:r>
+            <a:r>
+              <a:rPr lang="ko-KR" altLang="en-US" baseline="0" dirty="0" err="1" smtClean="0"/>
+              <a:t>번들링이라고</a:t>
+            </a:r>
+            <a:r>
+              <a:rPr lang="ko-KR" altLang="en-US" baseline="0" dirty="0" smtClean="0"/>
+              <a:t> 하며</a:t>
+            </a:r>
+            <a:r>
+              <a:rPr lang="en-US" altLang="ko-KR" baseline="0" dirty="0" smtClean="0"/>
+              <a:t>, </a:t>
+            </a:r>
+            <a:r>
+              <a:rPr lang="ko-KR" altLang="en-US" baseline="0" dirty="0" err="1" smtClean="0"/>
+              <a:t>번들링된</a:t>
+            </a:r>
+            <a:r>
+              <a:rPr lang="ko-KR" altLang="en-US" baseline="0" dirty="0" smtClean="0"/>
+              <a:t> 결과물은 브라우저에서 로드 된다</a:t>
+            </a:r>
+            <a:r>
+              <a:rPr lang="en-US" altLang="ko-KR" baseline="0" dirty="0" smtClean="0"/>
+              <a:t>.</a:t>
+            </a:r>
+          </a:p>
+          <a:p>
+            <a:pPr marL="171450" indent="-171450">
+              <a:buFontTx/>
+              <a:buChar char="-"/>
+            </a:pPr>
+            <a:endParaRPr lang="en-US" altLang="ko-KR" baseline="0" dirty="0" smtClean="0"/>
+          </a:p>
+          <a:p>
+            <a:pPr marL="0" indent="0">
+              <a:buFontTx/>
+              <a:buNone/>
+            </a:pPr>
+            <a:r>
+              <a:rPr lang="en-US" altLang="ko-KR" baseline="0" dirty="0" smtClean="0"/>
+              <a:t>** </a:t>
+            </a:r>
+            <a:r>
+              <a:rPr lang="ko-KR" altLang="en-US" baseline="0" dirty="0" smtClean="0"/>
+              <a:t>모듈 번들러</a:t>
+            </a:r>
+            <a:endParaRPr lang="en-US" altLang="ko-KR" baseline="0" dirty="0" smtClean="0"/>
+          </a:p>
+          <a:p>
+            <a:pPr marL="0" indent="0">
+              <a:buFontTx/>
+              <a:buNone/>
+            </a:pPr>
+            <a:r>
+              <a:rPr lang="en-US" altLang="ko-KR" baseline="0" dirty="0" smtClean="0"/>
+              <a:t>- </a:t>
+            </a:r>
+            <a:r>
+              <a:rPr lang="en-US" altLang="ko-KR" baseline="0" dirty="0" err="1" smtClean="0"/>
+              <a:t>Webpack</a:t>
+            </a:r>
+            <a:r>
+              <a:rPr lang="ko-KR" altLang="en-US" baseline="0" dirty="0" smtClean="0"/>
+              <a:t>은 기본적으로 모듈 </a:t>
+            </a:r>
+            <a:r>
+              <a:rPr lang="ko-KR" altLang="en-US" baseline="0" dirty="0" err="1" smtClean="0"/>
+              <a:t>번들러이다</a:t>
+            </a:r>
+            <a:r>
+              <a:rPr lang="en-US" altLang="ko-KR" baseline="0" dirty="0" smtClean="0"/>
+              <a:t>.</a:t>
+            </a:r>
+          </a:p>
+          <a:p>
+            <a:pPr marL="171450" indent="-171450">
+              <a:buFontTx/>
+              <a:buChar char="-"/>
+            </a:pPr>
+            <a:r>
+              <a:rPr lang="ko-KR" altLang="en-US" baseline="0" dirty="0" smtClean="0"/>
+              <a:t>이는 각각의 파일을 모듈로 취급하고</a:t>
+            </a:r>
+            <a:r>
+              <a:rPr lang="en-US" altLang="ko-KR" baseline="0" dirty="0" smtClean="0"/>
+              <a:t>, </a:t>
+            </a:r>
+            <a:r>
+              <a:rPr lang="ko-KR" altLang="en-US" baseline="0" dirty="0" smtClean="0"/>
+              <a:t>이들 간의 의존성을 분석하여 하나의 묶음으로 만드는 작업을 의미</a:t>
+            </a:r>
+            <a:r>
+              <a:rPr lang="en-US" altLang="ko-KR" baseline="0" dirty="0" smtClean="0"/>
+              <a:t>.</a:t>
+            </a:r>
+          </a:p>
+          <a:p>
+            <a:pPr marL="171450" indent="-171450">
+              <a:buFontTx/>
+              <a:buChar char="-"/>
+            </a:pPr>
+            <a:r>
+              <a:rPr lang="ko-KR" altLang="en-US" baseline="0" dirty="0" smtClean="0"/>
+              <a:t>모듈 시스템을 사용하면 코드의 구조화와 유지보수가 용이해진다</a:t>
+            </a:r>
+            <a:r>
+              <a:rPr lang="en-US" altLang="ko-KR" baseline="0" dirty="0" smtClean="0"/>
+              <a:t>.</a:t>
+            </a:r>
+          </a:p>
+          <a:p>
+            <a:pPr marL="171450" indent="-171450">
+              <a:buFontTx/>
+              <a:buChar char="-"/>
+            </a:pPr>
+            <a:endParaRPr lang="en-US" altLang="ko-KR" baseline="0" dirty="0"/>
+          </a:p>
+          <a:p>
+            <a:pPr marL="0" indent="0">
+              <a:buFontTx/>
+              <a:buNone/>
+            </a:pPr>
+            <a:r>
+              <a:rPr lang="en-US" altLang="ko-KR" baseline="0" dirty="0" smtClean="0"/>
+              <a:t>** </a:t>
+            </a:r>
+            <a:r>
+              <a:rPr lang="ko-KR" altLang="en-US" baseline="0" dirty="0" smtClean="0"/>
+              <a:t>개발 서버</a:t>
+            </a:r>
+            <a:endParaRPr lang="en-US" altLang="ko-KR" baseline="0" dirty="0" smtClean="0"/>
+          </a:p>
+          <a:p>
+            <a:pPr marL="171450" indent="-171450">
+              <a:buFontTx/>
+              <a:buChar char="-"/>
+            </a:pPr>
+            <a:r>
+              <a:rPr lang="en-US" altLang="ko-KR" baseline="0" dirty="0" err="1" smtClean="0"/>
+              <a:t>Webpack</a:t>
+            </a:r>
+            <a:r>
+              <a:rPr lang="ko-KR" altLang="en-US" baseline="0" dirty="0" smtClean="0"/>
+              <a:t>은 개발 중에 빠르게 변경 사항을 확인할 수 있도록 개발 서버를 제공</a:t>
+            </a:r>
+            <a:r>
+              <a:rPr lang="en-US" altLang="ko-KR" baseline="0" dirty="0" smtClean="0"/>
+              <a:t>. (</a:t>
+            </a:r>
+            <a:r>
+              <a:rPr lang="ko-KR" altLang="en-US" baseline="0" dirty="0" smtClean="0"/>
+              <a:t>도구</a:t>
+            </a:r>
+            <a:r>
+              <a:rPr lang="en-US" altLang="ko-KR" baseline="0" dirty="0" smtClean="0"/>
+              <a:t>)</a:t>
+            </a:r>
+          </a:p>
+          <a:p>
+            <a:pPr marL="171450" indent="-171450">
+              <a:buFontTx/>
+              <a:buChar char="-"/>
+            </a:pPr>
+            <a:r>
+              <a:rPr lang="ko-KR" altLang="en-US" baseline="0" dirty="0" smtClean="0"/>
+              <a:t>이 서버는 파일의 변경사항을 실시간으로 감지하여 자동으로 브라우저를 새로고침하고 적용된 결과를 보여준다</a:t>
+            </a:r>
+            <a:r>
+              <a:rPr lang="en-US" altLang="ko-KR" baseline="0" dirty="0" smtClean="0"/>
+              <a:t>.</a:t>
+            </a:r>
+          </a:p>
+          <a:p>
+            <a:pPr marL="171450" indent="-171450">
+              <a:buFontTx/>
+              <a:buChar char="-"/>
+            </a:pPr>
+            <a:r>
+              <a:rPr lang="ko-KR" altLang="en-US" baseline="0" dirty="0" smtClean="0"/>
+              <a:t>즉</a:t>
+            </a:r>
+            <a:r>
+              <a:rPr lang="en-US" altLang="ko-KR" baseline="0" dirty="0" smtClean="0"/>
+              <a:t>, </a:t>
+            </a:r>
+            <a:r>
+              <a:rPr lang="ko-KR" altLang="en-US" baseline="0" dirty="0" smtClean="0"/>
+              <a:t>소스 코드 파일 수정하면 </a:t>
+            </a:r>
+            <a:r>
+              <a:rPr lang="ko-KR" altLang="en-US" baseline="0" dirty="0" err="1" smtClean="0"/>
+              <a:t>새로고침</a:t>
+            </a:r>
+            <a:r>
+              <a:rPr lang="ko-KR" altLang="en-US" baseline="0" dirty="0" smtClean="0"/>
+              <a:t> 안해도 자동으로 해줌</a:t>
+            </a:r>
+            <a:r>
+              <a:rPr lang="en-US" altLang="ko-KR" baseline="0" dirty="0" smtClean="0"/>
+              <a:t>. ‘</a:t>
+            </a:r>
+            <a:r>
+              <a:rPr lang="ko-KR" altLang="en-US" baseline="0" dirty="0" smtClean="0"/>
+              <a:t>라이브</a:t>
+            </a:r>
+            <a:r>
+              <a:rPr lang="en-US" altLang="ko-KR" baseline="0" dirty="0" smtClean="0"/>
+              <a:t> </a:t>
+            </a:r>
+            <a:r>
+              <a:rPr lang="ko-KR" altLang="en-US" baseline="0" dirty="0" err="1" smtClean="0"/>
+              <a:t>리로딩</a:t>
+            </a:r>
+            <a:r>
+              <a:rPr lang="en-US" altLang="ko-KR" baseline="0" dirty="0" smtClean="0"/>
+              <a:t>’ </a:t>
+            </a:r>
+            <a:r>
+              <a:rPr lang="ko-KR" altLang="en-US" baseline="0" dirty="0" smtClean="0"/>
+              <a:t>이라고도 합니다</a:t>
+            </a:r>
+            <a:r>
+              <a:rPr lang="en-US" altLang="ko-KR" baseline="0" dirty="0" smtClean="0"/>
+              <a:t>.</a:t>
+            </a:r>
+          </a:p>
+          <a:p>
+            <a:pPr marL="171450" indent="-171450">
+              <a:buFontTx/>
+              <a:buChar char="-"/>
+            </a:pPr>
+            <a:r>
+              <a:rPr lang="ko-KR" altLang="en-US" baseline="0" dirty="0" err="1" smtClean="0"/>
+              <a:t>프론트엔드</a:t>
+            </a:r>
+            <a:r>
+              <a:rPr lang="ko-KR" altLang="en-US" baseline="0" dirty="0" smtClean="0"/>
+              <a:t> 개발에서의 </a:t>
+            </a:r>
+            <a:r>
+              <a:rPr lang="en-US" altLang="ko-KR" baseline="0" dirty="0" err="1" smtClean="0"/>
+              <a:t>nodemon</a:t>
+            </a:r>
+            <a:r>
+              <a:rPr lang="en-US" altLang="ko-KR" baseline="0" dirty="0" smtClean="0"/>
+              <a:t> </a:t>
+            </a:r>
+            <a:r>
+              <a:rPr lang="ko-KR" altLang="en-US" baseline="0" dirty="0" smtClean="0"/>
+              <a:t>같은 것이라고 이해 하면 됨</a:t>
+            </a:r>
+            <a:r>
+              <a:rPr lang="en-US" altLang="ko-KR" baseline="0" dirty="0" smtClean="0"/>
+              <a:t>!</a:t>
+            </a:r>
+          </a:p>
+          <a:p>
+            <a:pPr marL="171450" indent="-171450">
+              <a:buFontTx/>
+              <a:buChar char="-"/>
+            </a:pPr>
+            <a:endParaRPr lang="en-US" altLang="ko-KR" baseline="0" dirty="0" smtClean="0"/>
+          </a:p>
+          <a:p>
+            <a:pPr marL="171450" indent="-171450">
+              <a:buFontTx/>
+              <a:buChar char="-"/>
+            </a:pPr>
+            <a:r>
+              <a:rPr lang="en-US" altLang="ko-KR" baseline="0" dirty="0" err="1" smtClean="0"/>
+              <a:t>Webpack</a:t>
+            </a:r>
+            <a:r>
+              <a:rPr lang="ko-KR" altLang="en-US" baseline="0" dirty="0" smtClean="0"/>
+              <a:t>을 사용하면 코드의 구조를 </a:t>
+            </a:r>
+            <a:r>
+              <a:rPr lang="ko-KR" altLang="en-US" baseline="0" dirty="0" err="1" smtClean="0"/>
+              <a:t>모듈화하고</a:t>
+            </a:r>
+            <a:r>
+              <a:rPr lang="en-US" altLang="ko-KR" baseline="0" dirty="0" smtClean="0"/>
+              <a:t>, </a:t>
+            </a:r>
+            <a:r>
+              <a:rPr lang="ko-KR" altLang="en-US" baseline="0" dirty="0" smtClean="0"/>
+              <a:t>효율적으로 관리하며</a:t>
+            </a:r>
+            <a:r>
+              <a:rPr lang="en-US" altLang="ko-KR" baseline="0" dirty="0" smtClean="0"/>
+              <a:t>, </a:t>
+            </a:r>
+            <a:r>
+              <a:rPr lang="ko-KR" altLang="en-US" baseline="0" dirty="0" smtClean="0"/>
+              <a:t>성능을 최적화 할 수 있는 여러 가지 장점을 제공 받을 수 있다</a:t>
+            </a:r>
+            <a:r>
+              <a:rPr lang="en-US" altLang="ko-KR" baseline="0" dirty="0" smtClean="0"/>
+              <a:t>.</a:t>
+            </a:r>
+            <a:br>
+              <a:rPr lang="en-US" altLang="ko-KR" baseline="0" dirty="0" smtClean="0"/>
+            </a:br>
+            <a:endParaRPr lang="en-US" altLang="ko-KR" baseline="0" dirty="0" smtClean="0"/>
+          </a:p>
+          <a:p>
+            <a:pPr marL="0" indent="0">
+              <a:buFontTx/>
+              <a:buNone/>
+            </a:pPr>
+            <a:r>
+              <a:rPr lang="en-US" altLang="ko-KR" baseline="0" dirty="0" smtClean="0"/>
+              <a:t>** </a:t>
+            </a:r>
+            <a:r>
+              <a:rPr lang="ko-KR" altLang="en-US" baseline="0" dirty="0" smtClean="0"/>
+              <a:t>모듈이란</a:t>
+            </a:r>
+            <a:r>
+              <a:rPr lang="en-US" altLang="ko-KR" baseline="0" dirty="0" smtClean="0"/>
+              <a:t>?</a:t>
+            </a:r>
+          </a:p>
+          <a:p>
+            <a:pPr marL="0" indent="0">
+              <a:buFontTx/>
+              <a:buNone/>
+            </a:pPr>
+            <a:r>
+              <a:rPr lang="en-US" altLang="ko-KR" baseline="0" dirty="0" smtClean="0"/>
+              <a:t>- </a:t>
+            </a:r>
+            <a:r>
+              <a:rPr lang="ko-KR" altLang="en-US" baseline="0" dirty="0" err="1" smtClean="0"/>
+              <a:t>재사용성과</a:t>
+            </a:r>
+            <a:r>
+              <a:rPr lang="ko-KR" altLang="en-US" baseline="0" dirty="0" smtClean="0"/>
+              <a:t> 유지보수성을 높이기 위해 독립적인 단위로 분리된 코드 조각을 의미함</a:t>
+            </a:r>
+            <a:r>
+              <a:rPr lang="en-US" altLang="ko-KR" baseline="0" dirty="0" smtClean="0"/>
+              <a:t>.!</a:t>
+            </a:r>
+          </a:p>
+          <a:p>
+            <a:pPr marL="0" indent="0">
+              <a:buFontTx/>
+              <a:buNone/>
+            </a:pPr>
+            <a:r>
+              <a:rPr lang="en-US" altLang="ko-KR" baseline="0" dirty="0" smtClean="0"/>
+              <a:t>- </a:t>
+            </a:r>
+            <a:r>
+              <a:rPr lang="ko-KR" altLang="en-US" baseline="0" dirty="0" err="1" smtClean="0"/>
+              <a:t>캡슐화하여</a:t>
+            </a:r>
+            <a:r>
+              <a:rPr lang="ko-KR" altLang="en-US" baseline="0" dirty="0" smtClean="0"/>
+              <a:t> 다른 부분과 독립적으로 개발되고 사용될 수 있음</a:t>
+            </a:r>
+            <a:r>
+              <a:rPr lang="en-US" altLang="ko-KR" baseline="0" dirty="0" smtClean="0"/>
+              <a:t>.</a:t>
+            </a:r>
+            <a:br>
+              <a:rPr lang="en-US" altLang="ko-KR" baseline="0" dirty="0" smtClean="0"/>
+            </a:br>
+            <a:r>
+              <a:rPr lang="en-US" altLang="ko-KR" baseline="0" dirty="0" smtClean="0"/>
+              <a:t/>
+            </a:r>
+            <a:br>
+              <a:rPr lang="en-US" altLang="ko-KR" baseline="0" dirty="0" smtClean="0"/>
+            </a:br>
+            <a:r>
+              <a:rPr lang="ko-KR" altLang="en-US" sz="1200" b="0" i="0" kern="1200" dirty="0" smtClean="0">
+                <a:solidFill>
+                  <a:schemeClr val="tx1"/>
+                </a:solidFill>
+                <a:effectLst/>
+                <a:latin typeface="+mn-lt"/>
+                <a:ea typeface="+mn-ea"/>
+                <a:cs typeface="+mn-cs"/>
+              </a:rPr>
+              <a:t>모듈은 개별적으로 존재했을 때는 재사용이 불가능하므로</a:t>
+            </a:r>
+            <a:r>
+              <a:rPr lang="en-US" altLang="ko-KR" sz="1200" b="0" i="0" kern="1200" dirty="0" smtClean="0">
+                <a:solidFill>
+                  <a:schemeClr val="tx1"/>
+                </a:solidFill>
+                <a:effectLst/>
+                <a:latin typeface="+mn-lt"/>
+                <a:ea typeface="+mn-ea"/>
+                <a:cs typeface="+mn-cs"/>
+              </a:rPr>
+              <a:t>, </a:t>
+            </a:r>
+            <a:r>
+              <a:rPr lang="ko-KR" altLang="en-US" sz="1200" b="0" i="0" kern="1200" dirty="0" smtClean="0">
+                <a:solidFill>
+                  <a:schemeClr val="tx1"/>
+                </a:solidFill>
+                <a:effectLst/>
+                <a:latin typeface="+mn-lt"/>
+                <a:ea typeface="+mn-ea"/>
+                <a:cs typeface="+mn-cs"/>
+              </a:rPr>
+              <a:t>존재의 의미가 없고 다른 모듈에 의해 재사용되어야 의미가 있습니다</a:t>
+            </a:r>
+            <a:r>
+              <a:rPr lang="en-US" altLang="ko-KR" sz="1200" b="0" i="0" kern="1200" dirty="0" smtClean="0">
+                <a:solidFill>
+                  <a:schemeClr val="tx1"/>
+                </a:solidFill>
+                <a:effectLst/>
+                <a:latin typeface="+mn-lt"/>
+                <a:ea typeface="+mn-ea"/>
+                <a:cs typeface="+mn-cs"/>
+              </a:rPr>
+              <a:t>. </a:t>
+            </a:r>
+            <a:br>
+              <a:rPr lang="en-US" altLang="ko-KR" sz="1200" b="0" i="0" kern="1200" dirty="0" smtClean="0">
+                <a:solidFill>
+                  <a:schemeClr val="tx1"/>
+                </a:solidFill>
+                <a:effectLst/>
+                <a:latin typeface="+mn-lt"/>
+                <a:ea typeface="+mn-ea"/>
+                <a:cs typeface="+mn-cs"/>
+              </a:rPr>
+            </a:br>
+            <a:r>
+              <a:rPr lang="en-US" altLang="ko-KR" sz="1200" b="0" i="0" kern="1200" dirty="0" smtClean="0">
+                <a:solidFill>
+                  <a:schemeClr val="tx1"/>
+                </a:solidFill>
+                <a:effectLst/>
+                <a:latin typeface="+mn-lt"/>
+                <a:ea typeface="+mn-ea"/>
+                <a:cs typeface="+mn-cs"/>
+              </a:rPr>
+              <a:t/>
+            </a:r>
+            <a:br>
+              <a:rPr lang="en-US" altLang="ko-KR" sz="1200" b="0" i="0" kern="1200" dirty="0" smtClean="0">
+                <a:solidFill>
+                  <a:schemeClr val="tx1"/>
+                </a:solidFill>
+                <a:effectLst/>
+                <a:latin typeface="+mn-lt"/>
+                <a:ea typeface="+mn-ea"/>
+                <a:cs typeface="+mn-cs"/>
+              </a:rPr>
+            </a:br>
+            <a:r>
+              <a:rPr lang="ko-KR" altLang="en-US" sz="1200" b="0" i="0" kern="1200" dirty="0" smtClean="0">
+                <a:solidFill>
+                  <a:schemeClr val="tx1"/>
+                </a:solidFill>
+                <a:effectLst/>
+                <a:latin typeface="+mn-lt"/>
+                <a:ea typeface="+mn-ea"/>
+                <a:cs typeface="+mn-cs"/>
+              </a:rPr>
+              <a:t>따라서 모듈은 공개가 필요한 자산에 한정해 명시적으로 선택적 공개가 가능합니다</a:t>
+            </a:r>
+            <a:r>
+              <a:rPr lang="en-US" altLang="ko-KR" sz="1200" b="0" i="0" kern="1200" dirty="0" smtClean="0">
+                <a:solidFill>
+                  <a:schemeClr val="tx1"/>
+                </a:solidFill>
+                <a:effectLst/>
+                <a:latin typeface="+mn-lt"/>
+                <a:ea typeface="+mn-ea"/>
+                <a:cs typeface="+mn-cs"/>
+              </a:rPr>
+              <a:t>. </a:t>
+            </a:r>
+            <a:r>
+              <a:rPr lang="ko-KR" altLang="en-US" sz="1200" b="0" i="0" kern="1200" dirty="0" smtClean="0">
+                <a:solidFill>
+                  <a:schemeClr val="tx1"/>
+                </a:solidFill>
+                <a:effectLst/>
+                <a:latin typeface="+mn-lt"/>
+                <a:ea typeface="+mn-ea"/>
+                <a:cs typeface="+mn-cs"/>
+              </a:rPr>
+              <a:t>이를 </a:t>
+            </a:r>
+            <a:r>
+              <a:rPr lang="en-US" altLang="ko-KR" sz="1200" b="0" i="0" kern="1200" dirty="0" smtClean="0">
+                <a:solidFill>
+                  <a:schemeClr val="tx1"/>
+                </a:solidFill>
+                <a:effectLst/>
+                <a:latin typeface="+mn-lt"/>
+                <a:ea typeface="+mn-ea"/>
+                <a:cs typeface="+mn-cs"/>
+              </a:rPr>
+              <a:t>export </a:t>
+            </a:r>
+            <a:r>
+              <a:rPr lang="ko-KR" altLang="en-US" sz="1200" b="0" i="0" kern="1200" dirty="0" smtClean="0">
+                <a:solidFill>
+                  <a:schemeClr val="tx1"/>
+                </a:solidFill>
+                <a:effectLst/>
+                <a:latin typeface="+mn-lt"/>
+                <a:ea typeface="+mn-ea"/>
+                <a:cs typeface="+mn-cs"/>
+              </a:rPr>
+              <a:t>라고 합니다</a:t>
+            </a:r>
+            <a:r>
+              <a:rPr lang="en-US" altLang="ko-KR" sz="1200" b="0" i="0" kern="1200" dirty="0" smtClean="0">
+                <a:solidFill>
+                  <a:schemeClr val="tx1"/>
+                </a:solidFill>
+                <a:effectLst/>
+                <a:latin typeface="+mn-lt"/>
+                <a:ea typeface="+mn-ea"/>
+                <a:cs typeface="+mn-cs"/>
+              </a:rPr>
+              <a:t>.</a:t>
+            </a:r>
+            <a:br>
+              <a:rPr lang="en-US" altLang="ko-KR" sz="1200" b="0" i="0" kern="1200" dirty="0" smtClean="0">
+                <a:solidFill>
+                  <a:schemeClr val="tx1"/>
+                </a:solidFill>
+                <a:effectLst/>
+                <a:latin typeface="+mn-lt"/>
+                <a:ea typeface="+mn-ea"/>
+                <a:cs typeface="+mn-cs"/>
+              </a:rPr>
+            </a:br>
+            <a:r>
+              <a:rPr lang="en-US" altLang="ko-KR" sz="1200" b="0" i="0" kern="1200" dirty="0" smtClean="0">
+                <a:solidFill>
+                  <a:schemeClr val="tx1"/>
+                </a:solidFill>
+                <a:effectLst/>
+                <a:latin typeface="+mn-lt"/>
+                <a:ea typeface="+mn-ea"/>
+                <a:cs typeface="+mn-cs"/>
+              </a:rPr>
+              <a:t/>
+            </a:r>
+            <a:br>
+              <a:rPr lang="en-US" altLang="ko-KR" sz="1200" b="0" i="0" kern="1200" dirty="0" smtClean="0">
+                <a:solidFill>
+                  <a:schemeClr val="tx1"/>
+                </a:solidFill>
+                <a:effectLst/>
+                <a:latin typeface="+mn-lt"/>
+                <a:ea typeface="+mn-ea"/>
+                <a:cs typeface="+mn-cs"/>
+              </a:rPr>
+            </a:br>
+            <a:r>
+              <a:rPr lang="ko-KR" altLang="en-US" sz="1200" b="0" i="0" kern="1200" dirty="0" smtClean="0">
+                <a:solidFill>
+                  <a:schemeClr val="tx1"/>
+                </a:solidFill>
+                <a:effectLst/>
+                <a:latin typeface="+mn-lt"/>
+                <a:ea typeface="+mn-ea"/>
+                <a:cs typeface="+mn-cs"/>
+              </a:rPr>
+              <a:t>모듈 사용자는 </a:t>
+            </a:r>
+            <a:r>
+              <a:rPr lang="en-US" altLang="ko-KR" sz="1200" b="0" i="0" kern="1200" dirty="0" smtClean="0">
+                <a:solidFill>
+                  <a:schemeClr val="tx1"/>
+                </a:solidFill>
+                <a:effectLst/>
+                <a:latin typeface="+mn-lt"/>
+                <a:ea typeface="+mn-ea"/>
+                <a:cs typeface="+mn-cs"/>
+              </a:rPr>
+              <a:t>import </a:t>
+            </a:r>
+            <a:r>
+              <a:rPr lang="ko-KR" altLang="en-US" sz="1200" b="0" i="0" kern="1200" dirty="0" smtClean="0">
+                <a:solidFill>
+                  <a:schemeClr val="tx1"/>
+                </a:solidFill>
+                <a:effectLst/>
+                <a:latin typeface="+mn-lt"/>
+                <a:ea typeface="+mn-ea"/>
+                <a:cs typeface="+mn-cs"/>
+              </a:rPr>
+              <a:t>를 통해 다른 모듈을 선택해 자신의 </a:t>
+            </a:r>
+            <a:r>
+              <a:rPr lang="ko-KR" altLang="en-US" sz="1200" b="0" i="0" kern="1200" dirty="0" err="1" smtClean="0">
+                <a:solidFill>
+                  <a:schemeClr val="tx1"/>
+                </a:solidFill>
+                <a:effectLst/>
+                <a:latin typeface="+mn-lt"/>
+                <a:ea typeface="+mn-ea"/>
+                <a:cs typeface="+mn-cs"/>
+              </a:rPr>
+              <a:t>스코프</a:t>
+            </a:r>
+            <a:r>
+              <a:rPr lang="ko-KR" altLang="en-US" sz="1200" b="0" i="0" kern="1200" dirty="0" smtClean="0">
+                <a:solidFill>
+                  <a:schemeClr val="tx1"/>
+                </a:solidFill>
+                <a:effectLst/>
+                <a:latin typeface="+mn-lt"/>
+                <a:ea typeface="+mn-ea"/>
+                <a:cs typeface="+mn-cs"/>
+              </a:rPr>
+              <a:t> 내로 불러들여 재사용할 수 있습니다</a:t>
+            </a:r>
+            <a:r>
+              <a:rPr lang="en-US" altLang="ko-KR" sz="1200" b="0" i="0" kern="1200" dirty="0" smtClean="0">
+                <a:solidFill>
+                  <a:schemeClr val="tx1"/>
+                </a:solidFill>
+                <a:effectLst/>
+                <a:latin typeface="+mn-lt"/>
+                <a:ea typeface="+mn-ea"/>
+                <a:cs typeface="+mn-cs"/>
+              </a:rPr>
+              <a:t>.</a:t>
+            </a:r>
+            <a:br>
+              <a:rPr lang="en-US" altLang="ko-KR" sz="1200" b="0" i="0" kern="1200" dirty="0" smtClean="0">
+                <a:solidFill>
+                  <a:schemeClr val="tx1"/>
+                </a:solidFill>
+                <a:effectLst/>
+                <a:latin typeface="+mn-lt"/>
+                <a:ea typeface="+mn-ea"/>
+                <a:cs typeface="+mn-cs"/>
+              </a:rPr>
+            </a:br>
+            <a:r>
+              <a:rPr lang="en-US" altLang="ko-KR" sz="1200" b="0" i="0" kern="1200" dirty="0" smtClean="0">
+                <a:solidFill>
+                  <a:schemeClr val="tx1"/>
+                </a:solidFill>
+                <a:effectLst/>
+                <a:latin typeface="+mn-lt"/>
+                <a:ea typeface="+mn-ea"/>
+                <a:cs typeface="+mn-cs"/>
+              </a:rPr>
+              <a:t/>
+            </a:r>
+            <a:br>
+              <a:rPr lang="en-US" altLang="ko-KR" sz="1200" b="0" i="0" kern="1200" dirty="0" smtClean="0">
+                <a:solidFill>
+                  <a:schemeClr val="tx1"/>
+                </a:solidFill>
+                <a:effectLst/>
+                <a:latin typeface="+mn-lt"/>
+                <a:ea typeface="+mn-ea"/>
+                <a:cs typeface="+mn-cs"/>
+              </a:rPr>
+            </a:br>
+            <a:r>
+              <a:rPr lang="en-US" altLang="ko-KR" sz="1200" b="0" i="0" kern="1200" dirty="0" smtClean="0">
+                <a:solidFill>
+                  <a:schemeClr val="tx1"/>
+                </a:solidFill>
+                <a:effectLst/>
+                <a:latin typeface="+mn-lt"/>
+                <a:ea typeface="+mn-ea"/>
+                <a:cs typeface="+mn-cs"/>
+              </a:rPr>
+              <a:t/>
+            </a:r>
+            <a:br>
+              <a:rPr lang="en-US" altLang="ko-KR" sz="1200" b="0" i="0" kern="1200" dirty="0" smtClean="0">
+                <a:solidFill>
+                  <a:schemeClr val="tx1"/>
+                </a:solidFill>
+                <a:effectLst/>
+                <a:latin typeface="+mn-lt"/>
+                <a:ea typeface="+mn-ea"/>
+                <a:cs typeface="+mn-cs"/>
+              </a:rPr>
+            </a:br>
+            <a:r>
+              <a:rPr lang="en-US" altLang="ko-KR" sz="1200" b="0" i="0" kern="1200" dirty="0" smtClean="0">
+                <a:solidFill>
+                  <a:schemeClr val="tx1"/>
+                </a:solidFill>
+                <a:effectLst/>
+                <a:latin typeface="+mn-lt"/>
+                <a:ea typeface="+mn-ea"/>
+                <a:cs typeface="+mn-cs"/>
+              </a:rPr>
+              <a:t>***TMI</a:t>
+            </a:r>
+          </a:p>
+          <a:p>
+            <a:pPr marL="0" indent="0">
+              <a:buFontTx/>
+              <a:buNone/>
+            </a:pPr>
+            <a:r>
+              <a:rPr lang="ko-KR" altLang="en-US" sz="1200" b="0" i="0" kern="1200" baseline="0" dirty="0" smtClean="0">
+                <a:solidFill>
+                  <a:schemeClr val="tx1"/>
+                </a:solidFill>
+                <a:effectLst/>
+                <a:latin typeface="+mn-lt"/>
+                <a:ea typeface="+mn-ea"/>
+                <a:cs typeface="+mn-cs"/>
+              </a:rPr>
+              <a:t>왜 </a:t>
+            </a:r>
+            <a:r>
+              <a:rPr lang="ko-KR" altLang="en-US" sz="1200" b="0" i="0" kern="1200" baseline="0" dirty="0" err="1" smtClean="0">
+                <a:solidFill>
+                  <a:schemeClr val="tx1"/>
+                </a:solidFill>
+                <a:effectLst/>
+                <a:latin typeface="+mn-lt"/>
+                <a:ea typeface="+mn-ea"/>
+                <a:cs typeface="+mn-cs"/>
+              </a:rPr>
+              <a:t>번들링을</a:t>
+            </a:r>
+            <a:r>
+              <a:rPr lang="ko-KR" altLang="en-US" sz="1200" b="0" i="0" kern="1200" baseline="0" dirty="0" smtClean="0">
+                <a:solidFill>
+                  <a:schemeClr val="tx1"/>
+                </a:solidFill>
+                <a:effectLst/>
+                <a:latin typeface="+mn-lt"/>
+                <a:ea typeface="+mn-ea"/>
+                <a:cs typeface="+mn-cs"/>
+              </a:rPr>
+              <a:t> 해줘야 할까</a:t>
+            </a:r>
+            <a:r>
+              <a:rPr lang="en-US" altLang="ko-KR" sz="1200" b="0" i="0" kern="1200" baseline="0" dirty="0" smtClean="0">
+                <a:solidFill>
+                  <a:schemeClr val="tx1"/>
+                </a:solidFill>
+                <a:effectLst/>
+                <a:latin typeface="+mn-lt"/>
+                <a:ea typeface="+mn-ea"/>
+                <a:cs typeface="+mn-cs"/>
+              </a:rPr>
+              <a:t>?</a:t>
+            </a:r>
+          </a:p>
+          <a:p>
+            <a:pPr marL="171450" indent="-171450">
+              <a:buFontTx/>
+              <a:buChar char="-"/>
+            </a:pPr>
+            <a:r>
+              <a:rPr lang="en-US" altLang="ko-KR" sz="1200" b="0" i="0" kern="1200" baseline="0" dirty="0" smtClean="0">
+                <a:solidFill>
+                  <a:schemeClr val="tx1"/>
+                </a:solidFill>
+                <a:effectLst/>
+                <a:latin typeface="+mn-lt"/>
+                <a:ea typeface="+mn-ea"/>
+                <a:cs typeface="+mn-cs"/>
+              </a:rPr>
+              <a:t>1. </a:t>
+            </a:r>
+            <a:r>
+              <a:rPr lang="ko-KR" altLang="en-US" sz="1200" b="0" i="0" kern="1200" baseline="0" dirty="0" smtClean="0">
+                <a:solidFill>
+                  <a:schemeClr val="tx1"/>
+                </a:solidFill>
+                <a:effectLst/>
+                <a:latin typeface="+mn-lt"/>
+                <a:ea typeface="+mn-ea"/>
+                <a:cs typeface="+mn-cs"/>
+              </a:rPr>
+              <a:t>파일 관리의 복잡성 증가</a:t>
+            </a:r>
+            <a:r>
+              <a:rPr lang="en-US" altLang="ko-KR" sz="1200" b="0" i="0" kern="1200" baseline="0" dirty="0" smtClean="0">
+                <a:solidFill>
+                  <a:schemeClr val="tx1"/>
+                </a:solidFill>
+                <a:effectLst/>
+                <a:latin typeface="+mn-lt"/>
+                <a:ea typeface="+mn-ea"/>
+                <a:cs typeface="+mn-cs"/>
+              </a:rPr>
+              <a:t>.</a:t>
+            </a:r>
+          </a:p>
+          <a:p>
+            <a:pPr marL="171450" indent="-171450">
+              <a:buFontTx/>
+              <a:buChar char="-"/>
+            </a:pPr>
+            <a:r>
+              <a:rPr lang="ko-KR" altLang="en-US" sz="1200" b="0" i="0" kern="1200" baseline="0" dirty="0" smtClean="0">
+                <a:solidFill>
+                  <a:schemeClr val="tx1"/>
+                </a:solidFill>
+                <a:effectLst/>
+                <a:latin typeface="+mn-lt"/>
+                <a:ea typeface="+mn-ea"/>
+                <a:cs typeface="+mn-cs"/>
+              </a:rPr>
+              <a:t>많은 파일 요청 </a:t>
+            </a:r>
+            <a:r>
+              <a:rPr lang="en-US" altLang="ko-KR" sz="1200" b="0" i="0" kern="1200" baseline="0" dirty="0" smtClean="0">
+                <a:solidFill>
+                  <a:schemeClr val="tx1"/>
+                </a:solidFill>
+                <a:effectLst/>
+                <a:latin typeface="+mn-lt"/>
+                <a:ea typeface="+mn-ea"/>
+                <a:cs typeface="+mn-cs"/>
+              </a:rPr>
+              <a:t>: </a:t>
+            </a:r>
+            <a:r>
+              <a:rPr lang="ko-KR" altLang="en-US" sz="1200" b="0" i="0" kern="1200" baseline="0" dirty="0" smtClean="0">
+                <a:solidFill>
+                  <a:schemeClr val="tx1"/>
+                </a:solidFill>
+                <a:effectLst/>
+                <a:latin typeface="+mn-lt"/>
+                <a:ea typeface="+mn-ea"/>
+                <a:cs typeface="+mn-cs"/>
+              </a:rPr>
+              <a:t>애플리케이션이 여러 개의 </a:t>
+            </a:r>
+            <a:r>
+              <a:rPr lang="en-US" altLang="ko-KR" sz="1200" b="0" i="0" kern="1200" baseline="0" dirty="0" smtClean="0">
+                <a:solidFill>
+                  <a:schemeClr val="tx1"/>
+                </a:solidFill>
+                <a:effectLst/>
+                <a:latin typeface="+mn-lt"/>
+                <a:ea typeface="+mn-ea"/>
+                <a:cs typeface="+mn-cs"/>
+              </a:rPr>
+              <a:t>JS </a:t>
+            </a:r>
+            <a:r>
+              <a:rPr lang="ko-KR" altLang="en-US" sz="1200" b="0" i="0" kern="1200" baseline="0" dirty="0" smtClean="0">
+                <a:solidFill>
+                  <a:schemeClr val="tx1"/>
+                </a:solidFill>
+                <a:effectLst/>
+                <a:latin typeface="+mn-lt"/>
+                <a:ea typeface="+mn-ea"/>
+                <a:cs typeface="+mn-cs"/>
+              </a:rPr>
+              <a:t>파일</a:t>
+            </a:r>
+            <a:r>
+              <a:rPr lang="en-US" altLang="ko-KR" sz="1200" b="0" i="0" kern="1200" baseline="0" dirty="0" smtClean="0">
+                <a:solidFill>
+                  <a:schemeClr val="tx1"/>
+                </a:solidFill>
+                <a:effectLst/>
+                <a:latin typeface="+mn-lt"/>
+                <a:ea typeface="+mn-ea"/>
+                <a:cs typeface="+mn-cs"/>
+              </a:rPr>
+              <a:t>, CSS</a:t>
+            </a:r>
+            <a:r>
+              <a:rPr lang="ko-KR" altLang="en-US" sz="1200" b="0" i="0" kern="1200" baseline="0" dirty="0" smtClean="0">
+                <a:solidFill>
+                  <a:schemeClr val="tx1"/>
+                </a:solidFill>
+                <a:effectLst/>
+                <a:latin typeface="+mn-lt"/>
+                <a:ea typeface="+mn-ea"/>
+                <a:cs typeface="+mn-cs"/>
+              </a:rPr>
+              <a:t>파일</a:t>
+            </a:r>
+            <a:r>
+              <a:rPr lang="en-US" altLang="ko-KR" sz="1200" b="0" i="0" kern="1200" baseline="0" dirty="0" smtClean="0">
+                <a:solidFill>
+                  <a:schemeClr val="tx1"/>
+                </a:solidFill>
+                <a:effectLst/>
+                <a:latin typeface="+mn-lt"/>
+                <a:ea typeface="+mn-ea"/>
+                <a:cs typeface="+mn-cs"/>
+              </a:rPr>
+              <a:t>, </a:t>
+            </a:r>
+            <a:r>
+              <a:rPr lang="ko-KR" altLang="en-US" sz="1200" b="0" i="0" kern="1200" baseline="0" dirty="0" smtClean="0">
+                <a:solidFill>
+                  <a:schemeClr val="tx1"/>
+                </a:solidFill>
+                <a:effectLst/>
+                <a:latin typeface="+mn-lt"/>
+                <a:ea typeface="+mn-ea"/>
+                <a:cs typeface="+mn-cs"/>
+              </a:rPr>
+              <a:t>이미지 파일 등을 </a:t>
+            </a:r>
+            <a:r>
+              <a:rPr lang="ko-KR" altLang="en-US" sz="1200" b="0" i="0" kern="1200" baseline="0" dirty="0" err="1" smtClean="0">
+                <a:solidFill>
+                  <a:schemeClr val="tx1"/>
+                </a:solidFill>
+                <a:effectLst/>
+                <a:latin typeface="+mn-lt"/>
+                <a:ea typeface="+mn-ea"/>
+                <a:cs typeface="+mn-cs"/>
+              </a:rPr>
+              <a:t>로드해야</a:t>
+            </a:r>
+            <a:r>
+              <a:rPr lang="ko-KR" altLang="en-US" sz="1200" b="0" i="0" kern="1200" baseline="0" dirty="0" smtClean="0">
+                <a:solidFill>
+                  <a:schemeClr val="tx1"/>
+                </a:solidFill>
+                <a:effectLst/>
+                <a:latin typeface="+mn-lt"/>
+                <a:ea typeface="+mn-ea"/>
+                <a:cs typeface="+mn-cs"/>
+              </a:rPr>
+              <a:t> 한다면</a:t>
+            </a:r>
+            <a:r>
+              <a:rPr lang="en-US" altLang="ko-KR" sz="1200" b="0" i="0" kern="1200" baseline="0" dirty="0" smtClean="0">
+                <a:solidFill>
+                  <a:schemeClr val="tx1"/>
+                </a:solidFill>
+                <a:effectLst/>
+                <a:latin typeface="+mn-lt"/>
+                <a:ea typeface="+mn-ea"/>
+                <a:cs typeface="+mn-cs"/>
+              </a:rPr>
+              <a:t>,</a:t>
+            </a:r>
+            <a:br>
+              <a:rPr lang="en-US" altLang="ko-KR" sz="1200" b="0" i="0" kern="1200" baseline="0" dirty="0" smtClean="0">
+                <a:solidFill>
+                  <a:schemeClr val="tx1"/>
+                </a:solidFill>
+                <a:effectLst/>
+                <a:latin typeface="+mn-lt"/>
+                <a:ea typeface="+mn-ea"/>
+                <a:cs typeface="+mn-cs"/>
+              </a:rPr>
+            </a:br>
+            <a:r>
+              <a:rPr lang="ko-KR" altLang="en-US" sz="1200" b="0" i="0" kern="1200" baseline="0" dirty="0" smtClean="0">
+                <a:solidFill>
+                  <a:schemeClr val="tx1"/>
+                </a:solidFill>
+                <a:effectLst/>
+                <a:latin typeface="+mn-lt"/>
+                <a:ea typeface="+mn-ea"/>
+                <a:cs typeface="+mn-cs"/>
+              </a:rPr>
+              <a:t>브라우저는 각각의 파일에 대해 서버에 요청을 보내야 함</a:t>
+            </a:r>
+            <a:r>
+              <a:rPr lang="en-US" altLang="ko-KR" sz="1200" b="0" i="0" kern="1200" baseline="0" dirty="0" smtClean="0">
+                <a:solidFill>
+                  <a:schemeClr val="tx1"/>
+                </a:solidFill>
+                <a:effectLst/>
+                <a:latin typeface="+mn-lt"/>
+                <a:ea typeface="+mn-ea"/>
+                <a:cs typeface="+mn-cs"/>
+              </a:rPr>
+              <a:t>.</a:t>
+            </a:r>
+            <a:br>
+              <a:rPr lang="en-US" altLang="ko-KR" sz="1200" b="0" i="0" kern="1200" baseline="0" dirty="0" smtClean="0">
+                <a:solidFill>
+                  <a:schemeClr val="tx1"/>
+                </a:solidFill>
+                <a:effectLst/>
+                <a:latin typeface="+mn-lt"/>
+                <a:ea typeface="+mn-ea"/>
+                <a:cs typeface="+mn-cs"/>
+              </a:rPr>
+            </a:br>
+            <a:r>
+              <a:rPr lang="en-US" altLang="ko-KR" sz="1200" b="0" i="0" kern="1200" baseline="0" dirty="0" smtClean="0">
+                <a:solidFill>
+                  <a:schemeClr val="tx1"/>
+                </a:solidFill>
+                <a:effectLst/>
+                <a:latin typeface="+mn-lt"/>
+                <a:ea typeface="+mn-ea"/>
+                <a:cs typeface="+mn-cs"/>
+              </a:rPr>
+              <a:t>-&gt; </a:t>
+            </a:r>
+            <a:r>
+              <a:rPr lang="ko-KR" altLang="en-US" sz="1200" b="0" i="0" kern="1200" baseline="0" dirty="0" smtClean="0">
+                <a:solidFill>
+                  <a:schemeClr val="tx1"/>
+                </a:solidFill>
+                <a:effectLst/>
+                <a:latin typeface="+mn-lt"/>
+                <a:ea typeface="+mn-ea"/>
+                <a:cs typeface="+mn-cs"/>
+              </a:rPr>
+              <a:t>그러면 네트워크 부하 증가</a:t>
+            </a:r>
+            <a:r>
+              <a:rPr lang="en-US" altLang="ko-KR" sz="1200" b="0" i="0" kern="1200" baseline="0" dirty="0" smtClean="0">
+                <a:solidFill>
+                  <a:schemeClr val="tx1"/>
+                </a:solidFill>
+                <a:effectLst/>
+                <a:latin typeface="+mn-lt"/>
+                <a:ea typeface="+mn-ea"/>
+                <a:cs typeface="+mn-cs"/>
+              </a:rPr>
+              <a:t>, </a:t>
+            </a:r>
+            <a:r>
+              <a:rPr lang="ko-KR" altLang="en-US" sz="1200" b="0" i="0" kern="1200" baseline="0" dirty="0" smtClean="0">
+                <a:solidFill>
+                  <a:schemeClr val="tx1"/>
+                </a:solidFill>
+                <a:effectLst/>
+                <a:latin typeface="+mn-lt"/>
+                <a:ea typeface="+mn-ea"/>
+                <a:cs typeface="+mn-cs"/>
+              </a:rPr>
+              <a:t>페이지 </a:t>
+            </a:r>
+            <a:r>
+              <a:rPr lang="ko-KR" altLang="en-US" sz="1200" b="0" i="0" kern="1200" baseline="0" dirty="0" err="1" smtClean="0">
+                <a:solidFill>
+                  <a:schemeClr val="tx1"/>
+                </a:solidFill>
+                <a:effectLst/>
+                <a:latin typeface="+mn-lt"/>
+                <a:ea typeface="+mn-ea"/>
+                <a:cs typeface="+mn-cs"/>
+              </a:rPr>
+              <a:t>로딩속도</a:t>
+            </a:r>
+            <a:r>
+              <a:rPr lang="ko-KR" altLang="en-US" sz="1200" b="0" i="0" kern="1200" baseline="0" dirty="0" smtClean="0">
+                <a:solidFill>
+                  <a:schemeClr val="tx1"/>
+                </a:solidFill>
+                <a:effectLst/>
+                <a:latin typeface="+mn-lt"/>
+                <a:ea typeface="+mn-ea"/>
+                <a:cs typeface="+mn-cs"/>
+              </a:rPr>
+              <a:t> 저하</a:t>
+            </a:r>
+            <a:r>
+              <a:rPr lang="en-US" altLang="ko-KR" sz="1200" b="0" i="0" kern="1200" baseline="0" dirty="0" smtClean="0">
+                <a:solidFill>
+                  <a:schemeClr val="tx1"/>
+                </a:solidFill>
+                <a:effectLst/>
+                <a:latin typeface="+mn-lt"/>
+                <a:ea typeface="+mn-ea"/>
+                <a:cs typeface="+mn-cs"/>
+              </a:rPr>
+              <a:t>.</a:t>
+            </a:r>
+          </a:p>
+          <a:p>
+            <a:pPr marL="171450" indent="-171450">
+              <a:buFontTx/>
+              <a:buChar char="-"/>
+            </a:pPr>
+            <a:r>
+              <a:rPr lang="ko-KR" altLang="en-US" sz="1200" b="0" i="0" kern="1200" baseline="0" dirty="0" smtClean="0">
+                <a:solidFill>
+                  <a:schemeClr val="tx1"/>
+                </a:solidFill>
+                <a:effectLst/>
+                <a:latin typeface="+mn-lt"/>
+                <a:ea typeface="+mn-ea"/>
+                <a:cs typeface="+mn-cs"/>
+              </a:rPr>
+              <a:t>의존성 관리 어려움</a:t>
+            </a:r>
+            <a:r>
+              <a:rPr lang="en-US" altLang="ko-KR" sz="1200" b="0" i="0" kern="1200" baseline="0" dirty="0" smtClean="0">
+                <a:solidFill>
+                  <a:schemeClr val="tx1"/>
+                </a:solidFill>
+                <a:effectLst/>
+                <a:latin typeface="+mn-lt"/>
+                <a:ea typeface="+mn-ea"/>
+                <a:cs typeface="+mn-cs"/>
+              </a:rPr>
+              <a:t>.</a:t>
+            </a:r>
+            <a:br>
+              <a:rPr lang="en-US" altLang="ko-KR" sz="1200" b="0" i="0" kern="1200" baseline="0" dirty="0" smtClean="0">
+                <a:solidFill>
+                  <a:schemeClr val="tx1"/>
+                </a:solidFill>
+                <a:effectLst/>
+                <a:latin typeface="+mn-lt"/>
+                <a:ea typeface="+mn-ea"/>
+                <a:cs typeface="+mn-cs"/>
+              </a:rPr>
+            </a:br>
+            <a:r>
+              <a:rPr lang="en-US" altLang="ko-KR" sz="1200" b="0" i="0" kern="1200" baseline="0" dirty="0" smtClean="0">
+                <a:solidFill>
+                  <a:schemeClr val="tx1"/>
+                </a:solidFill>
+                <a:effectLst/>
+                <a:latin typeface="+mn-lt"/>
+                <a:ea typeface="+mn-ea"/>
+                <a:cs typeface="+mn-cs"/>
+              </a:rPr>
+              <a:t>-&gt; </a:t>
+            </a:r>
+            <a:r>
+              <a:rPr lang="ko-KR" altLang="en-US" sz="1200" b="0" i="0" kern="1200" baseline="0" dirty="0" smtClean="0">
+                <a:solidFill>
+                  <a:schemeClr val="tx1"/>
+                </a:solidFill>
+                <a:effectLst/>
+                <a:latin typeface="+mn-lt"/>
+                <a:ea typeface="+mn-ea"/>
+                <a:cs typeface="+mn-cs"/>
+              </a:rPr>
+              <a:t>모듈 간의 의존성을 수동을 관리해야 함</a:t>
+            </a:r>
+            <a:r>
+              <a:rPr lang="en-US" altLang="ko-KR" sz="1200" b="0" i="0" kern="1200" baseline="0" dirty="0" smtClean="0">
+                <a:solidFill>
+                  <a:schemeClr val="tx1"/>
+                </a:solidFill>
+                <a:effectLst/>
+                <a:latin typeface="+mn-lt"/>
+                <a:ea typeface="+mn-ea"/>
+                <a:cs typeface="+mn-cs"/>
+              </a:rPr>
+              <a:t>.</a:t>
+            </a:r>
+            <a:br>
+              <a:rPr lang="en-US" altLang="ko-KR" sz="1200" b="0" i="0" kern="1200" baseline="0" dirty="0" smtClean="0">
+                <a:solidFill>
+                  <a:schemeClr val="tx1"/>
+                </a:solidFill>
+                <a:effectLst/>
+                <a:latin typeface="+mn-lt"/>
+                <a:ea typeface="+mn-ea"/>
+                <a:cs typeface="+mn-cs"/>
+              </a:rPr>
+            </a:br>
+            <a:r>
+              <a:rPr lang="en-US" altLang="ko-KR" sz="1200" b="0" i="0" kern="1200" baseline="0" dirty="0" smtClean="0">
+                <a:solidFill>
+                  <a:schemeClr val="tx1"/>
+                </a:solidFill>
+                <a:effectLst/>
+                <a:latin typeface="+mn-lt"/>
+                <a:ea typeface="+mn-ea"/>
+                <a:cs typeface="+mn-cs"/>
+              </a:rPr>
+              <a:t>-&gt; </a:t>
+            </a:r>
+            <a:r>
+              <a:rPr lang="ko-KR" altLang="en-US" sz="1200" b="0" i="0" kern="1200" baseline="0" dirty="0" smtClean="0">
+                <a:solidFill>
+                  <a:schemeClr val="tx1"/>
+                </a:solidFill>
+                <a:effectLst/>
+                <a:latin typeface="+mn-lt"/>
+                <a:ea typeface="+mn-ea"/>
+                <a:cs typeface="+mn-cs"/>
+              </a:rPr>
+              <a:t>어떤 파일이 어떤 파일을 필요로 하는지 추적하는 것이 </a:t>
+            </a:r>
+            <a:r>
+              <a:rPr lang="ko-KR" altLang="en-US" sz="1200" b="0" i="0" kern="1200" baseline="0" dirty="0" err="1" smtClean="0">
+                <a:solidFill>
+                  <a:schemeClr val="tx1"/>
+                </a:solidFill>
+                <a:effectLst/>
+                <a:latin typeface="+mn-lt"/>
+                <a:ea typeface="+mn-ea"/>
+                <a:cs typeface="+mn-cs"/>
+              </a:rPr>
+              <a:t>복잡해짐</a:t>
+            </a:r>
+            <a:r>
+              <a:rPr lang="en-US" altLang="ko-KR" sz="1200" b="0" i="0" kern="1200" baseline="0" dirty="0" smtClean="0">
+                <a:solidFill>
+                  <a:schemeClr val="tx1"/>
+                </a:solidFill>
+                <a:effectLst/>
+                <a:latin typeface="+mn-lt"/>
+                <a:ea typeface="+mn-ea"/>
+                <a:cs typeface="+mn-cs"/>
+              </a:rPr>
+              <a:t>.</a:t>
+            </a:r>
+          </a:p>
+          <a:p>
+            <a:pPr marL="171450" indent="-171450">
+              <a:buFontTx/>
+              <a:buChar char="-"/>
+            </a:pPr>
+            <a:r>
+              <a:rPr lang="en-US" altLang="ko-KR" sz="1200" b="0" i="0" kern="1200" baseline="0" dirty="0" smtClean="0">
+                <a:solidFill>
+                  <a:schemeClr val="tx1"/>
+                </a:solidFill>
+                <a:effectLst/>
+                <a:latin typeface="+mn-lt"/>
+                <a:ea typeface="+mn-ea"/>
+                <a:cs typeface="+mn-cs"/>
+              </a:rPr>
+              <a:t>2. </a:t>
+            </a:r>
+            <a:r>
+              <a:rPr lang="ko-KR" altLang="en-US" sz="1200" b="0" i="0" kern="1200" baseline="0" dirty="0" smtClean="0">
+                <a:solidFill>
+                  <a:schemeClr val="tx1"/>
+                </a:solidFill>
+                <a:effectLst/>
+                <a:latin typeface="+mn-lt"/>
+                <a:ea typeface="+mn-ea"/>
+                <a:cs typeface="+mn-cs"/>
+              </a:rPr>
+              <a:t>성능저하</a:t>
+            </a:r>
+            <a:endParaRPr lang="en-US" altLang="ko-KR" sz="1200" b="0" i="0" kern="1200" baseline="0" dirty="0" smtClean="0">
+              <a:solidFill>
+                <a:schemeClr val="tx1"/>
+              </a:solidFill>
+              <a:effectLst/>
+              <a:latin typeface="+mn-lt"/>
+              <a:ea typeface="+mn-ea"/>
+              <a:cs typeface="+mn-cs"/>
+            </a:endParaRPr>
+          </a:p>
+          <a:p>
+            <a:pPr marL="171450" indent="-171450">
+              <a:buFontTx/>
+              <a:buChar char="-"/>
+            </a:pPr>
+            <a:r>
+              <a:rPr lang="en-US" altLang="ko-KR" sz="1200" b="0" i="0" kern="1200" baseline="0" dirty="0" smtClean="0">
+                <a:solidFill>
+                  <a:schemeClr val="tx1"/>
+                </a:solidFill>
+                <a:effectLst/>
+                <a:latin typeface="+mn-lt"/>
+                <a:ea typeface="+mn-ea"/>
+                <a:cs typeface="+mn-cs"/>
+              </a:rPr>
+              <a:t>3. </a:t>
+            </a:r>
+            <a:r>
+              <a:rPr lang="ko-KR" altLang="en-US" sz="1200" b="0" i="0" kern="1200" baseline="0" dirty="0" smtClean="0">
+                <a:solidFill>
+                  <a:schemeClr val="tx1"/>
+                </a:solidFill>
+                <a:effectLst/>
+                <a:latin typeface="+mn-lt"/>
+                <a:ea typeface="+mn-ea"/>
+                <a:cs typeface="+mn-cs"/>
+              </a:rPr>
+              <a:t>최적화 부족</a:t>
+            </a:r>
+            <a:endParaRPr lang="en-US" altLang="ko-KR" sz="1200" b="0" i="0" kern="1200" baseline="0" dirty="0" smtClean="0">
+              <a:solidFill>
+                <a:schemeClr val="tx1"/>
+              </a:solidFill>
+              <a:effectLst/>
+              <a:latin typeface="+mn-lt"/>
+              <a:ea typeface="+mn-ea"/>
+              <a:cs typeface="+mn-cs"/>
+            </a:endParaRPr>
+          </a:p>
+          <a:p>
+            <a:pPr marL="171450" indent="-171450">
+              <a:buFontTx/>
+              <a:buChar char="-"/>
+            </a:pPr>
+            <a:r>
+              <a:rPr lang="en-US" altLang="ko-KR" sz="1200" b="0" i="0" kern="1200" baseline="0" dirty="0" smtClean="0">
+                <a:solidFill>
+                  <a:schemeClr val="tx1"/>
+                </a:solidFill>
+                <a:effectLst/>
+                <a:latin typeface="+mn-lt"/>
+                <a:ea typeface="+mn-ea"/>
+                <a:cs typeface="+mn-cs"/>
+              </a:rPr>
+              <a:t>4. </a:t>
+            </a:r>
+            <a:r>
+              <a:rPr lang="ko-KR" altLang="en-US" sz="1200" b="0" i="0" kern="1200" baseline="0" dirty="0" smtClean="0">
+                <a:solidFill>
+                  <a:schemeClr val="tx1"/>
+                </a:solidFill>
+                <a:effectLst/>
+                <a:latin typeface="+mn-lt"/>
+                <a:ea typeface="+mn-ea"/>
+                <a:cs typeface="+mn-cs"/>
+              </a:rPr>
+              <a:t>모듈 시스템 부재</a:t>
+            </a:r>
+            <a:endParaRPr lang="en-US" altLang="ko-KR" baseline="0" dirty="0" smtClean="0"/>
+          </a:p>
+          <a:p>
+            <a:pPr marL="0" indent="0">
+              <a:buFontTx/>
+              <a:buNone/>
+            </a:pPr>
+            <a:endParaRPr lang="en-US" altLang="ko-KR" baseline="0" dirty="0" smtClean="0"/>
           </a:p>
         </p:txBody>
       </p:sp>
@@ -2766,11 +4277,49 @@
           <a:lstStyle/>
           <a:p>
             <a:r>
-              <a:rPr lang="en-US" altLang="ko-KR" dirty="0" err="1"/>
+              <a:rPr lang="ko-KR" altLang="en-US" dirty="0" smtClean="0"/>
+              <a:t>폴더 이름 </a:t>
+            </a:r>
+            <a:r>
+              <a:rPr lang="en-US" altLang="ko-KR" dirty="0" smtClean="0"/>
+              <a:t>= </a:t>
+            </a:r>
+            <a:r>
+              <a:rPr lang="ko-KR" altLang="en-US" dirty="0" err="1" smtClean="0"/>
+              <a:t>케밥</a:t>
+            </a:r>
+            <a:r>
+              <a:rPr lang="ko-KR" altLang="en-US" dirty="0" smtClean="0"/>
+              <a:t> 케이스</a:t>
+            </a:r>
+            <a:r>
+              <a:rPr lang="en-US" altLang="ko-KR" dirty="0" smtClean="0"/>
+              <a:t>, </a:t>
+            </a:r>
+            <a:r>
+              <a:rPr lang="ko-KR" altLang="en-US" dirty="0" err="1" smtClean="0"/>
+              <a:t>데쉬</a:t>
+            </a:r>
+            <a:r>
+              <a:rPr lang="en-US" altLang="ko-KR" dirty="0" smtClean="0"/>
+              <a:t>-</a:t>
+            </a:r>
+            <a:r>
+              <a:rPr lang="ko-KR" altLang="en-US" dirty="0" smtClean="0"/>
+              <a:t>케이스</a:t>
+            </a:r>
+            <a:endParaRPr lang="en-US" altLang="ko-KR" dirty="0" smtClean="0"/>
+          </a:p>
+          <a:p>
+            <a:endParaRPr lang="en-US" altLang="ko-KR" dirty="0" smtClean="0"/>
+          </a:p>
+          <a:p>
+            <a:r>
+              <a:rPr lang="en-US" altLang="ko-KR" dirty="0" err="1" smtClean="0"/>
               <a:t>npx</a:t>
             </a:r>
             <a:r>
-              <a:rPr lang="en-US" altLang="ko-KR" dirty="0"/>
+              <a:rPr lang="en-US" altLang="ko-KR" dirty="0" smtClean="0"/>
               <a:t> </a:t>
             </a:r>
             <a:r>
@@ -2806,12 +4355,8 @@
               <a:t>으로 설치 후에 </a:t>
             </a:r>
             <a:r>
-              <a:rPr lang="ko-KR" altLang="en-US" baseline="0" dirty="0" err="1"/>
-              <a:t>사용해야하지만</a:t>
-            </a:r>
-            <a:r>
-              <a:rPr lang="ko-KR" altLang="en-US" baseline="0" dirty="0"/>
-              <a:t> </a:t>
+              <a:rPr lang="ko-KR" altLang="en-US" baseline="0" dirty="0" smtClean="0"/>
+              <a:t>사용해야 하지만 </a:t>
             </a:r>
             <a:r>
               <a:rPr lang="en-US" altLang="ko-KR" baseline="0" dirty="0" err="1"/>
@@ -2823,7 +4368,104 @@
             </a:r>
             <a:r>
               <a:rPr lang="ko-KR" altLang="en-US" baseline="0" dirty="0"/>
-              <a:t>버전부터 추가된 패키지 사용 도구</a:t>
+              <a:t>버전부터 추가된 패키지 사용 </a:t>
+            </a:r>
+            <a:r>
+              <a:rPr lang="ko-KR" altLang="en-US" baseline="0" dirty="0" smtClean="0"/>
+              <a:t>도구</a:t>
+            </a:r>
+            <a:endParaRPr lang="en-US" altLang="ko-KR" baseline="0" dirty="0" smtClean="0"/>
+          </a:p>
+          <a:p>
+            <a:pPr marL="0" indent="0">
+              <a:buFontTx/>
+              <a:buNone/>
+            </a:pPr>
+            <a:endParaRPr lang="en-US" altLang="ko-KR" baseline="0" dirty="0" smtClean="0"/>
+          </a:p>
+          <a:p>
+            <a:pPr marL="0" indent="0">
+              <a:buFontTx/>
+              <a:buNone/>
+            </a:pPr>
+            <a:r>
+              <a:rPr lang="en-US" altLang="ko-KR" baseline="0" dirty="0" smtClean="0"/>
+              <a:t>**</a:t>
+            </a:r>
+            <a:r>
+              <a:rPr lang="ko-KR" altLang="en-US" baseline="0" dirty="0" smtClean="0"/>
+              <a:t>일회성 명령 실행</a:t>
+            </a:r>
+            <a:endParaRPr lang="en-US" altLang="ko-KR" baseline="0" dirty="0" smtClean="0"/>
+          </a:p>
+          <a:p>
+            <a:pPr marL="171450" indent="-171450">
+              <a:buFontTx/>
+              <a:buChar char="-"/>
+            </a:pPr>
+            <a:r>
+              <a:rPr lang="ko-KR" altLang="en-US" baseline="0" dirty="0" smtClean="0"/>
+              <a:t>패키지를 설치하지 않고도 직접 실행</a:t>
+            </a:r>
+            <a:endParaRPr lang="en-US" altLang="ko-KR" baseline="0" dirty="0" smtClean="0"/>
+          </a:p>
+          <a:p>
+            <a:pPr marL="171450" indent="-171450">
+              <a:buFontTx/>
+              <a:buChar char="-"/>
+            </a:pPr>
+            <a:r>
+              <a:rPr lang="ko-KR" altLang="en-US" baseline="0" dirty="0" smtClean="0"/>
+              <a:t>전역 설치를 피하고</a:t>
+            </a:r>
+            <a:r>
+              <a:rPr lang="en-US" altLang="ko-KR" baseline="0" dirty="0" smtClean="0"/>
+              <a:t>, </a:t>
+            </a:r>
+            <a:r>
+              <a:rPr lang="ko-KR" altLang="en-US" baseline="0" dirty="0" smtClean="0"/>
+              <a:t>환경을 깨끗하게 유지하게 해줌</a:t>
+            </a:r>
+            <a:r>
+              <a:rPr lang="en-US" altLang="ko-KR" baseline="0" dirty="0" smtClean="0"/>
+              <a:t>.</a:t>
+            </a:r>
+          </a:p>
+          <a:p>
+            <a:pPr marL="171450" indent="-171450">
+              <a:buFontTx/>
+              <a:buChar char="-"/>
+            </a:pPr>
+            <a:endParaRPr lang="en-US" altLang="ko-KR" baseline="0" dirty="0" smtClean="0"/>
+          </a:p>
+          <a:p>
+            <a:pPr marL="171450" indent="-171450">
+              <a:buFontTx/>
+              <a:buChar char="-"/>
+            </a:pPr>
+            <a:r>
+              <a:rPr lang="ko-KR" altLang="en-US" baseline="0" dirty="0" smtClean="0"/>
+              <a:t>즉</a:t>
+            </a:r>
+            <a:r>
+              <a:rPr lang="en-US" altLang="ko-KR" baseline="0" dirty="0" smtClean="0"/>
+              <a:t>, </a:t>
+            </a:r>
+            <a:r>
+              <a:rPr lang="ko-KR" altLang="en-US" baseline="0" dirty="0" smtClean="0"/>
+              <a:t>패키지의 글로벌 설치가 필요 없으며</a:t>
+            </a:r>
+            <a:r>
+              <a:rPr lang="en-US" altLang="ko-KR" baseline="0" dirty="0" smtClean="0"/>
+              <a:t>, </a:t>
+            </a:r>
+            <a:r>
+              <a:rPr lang="ko-KR" altLang="en-US" baseline="0" dirty="0" smtClean="0"/>
+              <a:t>특히 다양한 프로젝트에서 여러 패키지 버전 사용할 때 유용</a:t>
+            </a:r>
+            <a:r>
+              <a:rPr lang="en-US" altLang="ko-KR" baseline="0" dirty="0" smtClean="0"/>
+              <a:t>.</a:t>
             </a:r>
             <a:endParaRPr lang="en-US" altLang="ko-KR" baseline="0" dirty="0"/>
           </a:p>
@@ -2926,6 +4568,101 @@
             <a:endParaRPr lang="ko-KR" altLang="en-US" dirty="0"/>
           </a:p>
           <a:p>
+            <a:endParaRPr lang="en-US" altLang="ko-KR" dirty="0" smtClean="0"/>
+          </a:p>
+          <a:p>
+            <a:r>
+              <a:rPr lang="en-US" altLang="ko-KR" dirty="0" smtClean="0"/>
+              <a:t>** create-react-app</a:t>
+            </a:r>
+          </a:p>
+          <a:p>
+            <a:r>
+              <a:rPr lang="en-US" altLang="ko-KR" dirty="0" smtClean="0"/>
+              <a:t>16</a:t>
+            </a:r>
+            <a:r>
+              <a:rPr lang="ko-KR" altLang="en-US" dirty="0" smtClean="0"/>
+              <a:t>년 </a:t>
+            </a:r>
+            <a:r>
+              <a:rPr lang="en-US" altLang="ko-KR" dirty="0" smtClean="0"/>
+              <a:t>7</a:t>
+            </a:r>
+            <a:r>
+              <a:rPr lang="ko-KR" altLang="en-US" dirty="0" smtClean="0"/>
+              <a:t>월에 첫 출시</a:t>
+            </a:r>
+            <a:r>
+              <a:rPr lang="en-US" altLang="ko-KR" dirty="0" smtClean="0"/>
+              <a:t>.</a:t>
+            </a:r>
+          </a:p>
+          <a:p>
+            <a:r>
+              <a:rPr lang="en-US" altLang="ko-KR" dirty="0" smtClean="0"/>
+              <a:t>React </a:t>
+            </a:r>
+            <a:r>
+              <a:rPr lang="ko-KR" altLang="en-US" dirty="0" smtClean="0"/>
+              <a:t>애플리케이션 초기 설정을 간소화하고</a:t>
+            </a:r>
+            <a:r>
+              <a:rPr lang="en-US" altLang="ko-KR" dirty="0" smtClean="0"/>
+              <a:t>, </a:t>
+            </a:r>
+            <a:r>
+              <a:rPr lang="ko-KR" altLang="en-US" dirty="0" smtClean="0"/>
+              <a:t>별도 설정 없이 빠르게 프로젝트 시작 가능하게 해줌</a:t>
+            </a:r>
+            <a:r>
+              <a:rPr lang="en-US" altLang="ko-KR" dirty="0" smtClean="0"/>
+              <a:t>.</a:t>
+            </a:r>
+          </a:p>
+          <a:p>
+            <a:r>
+              <a:rPr lang="en-US" altLang="ko-KR" dirty="0" smtClean="0"/>
+              <a:t>CRA</a:t>
+            </a:r>
+            <a:r>
+              <a:rPr lang="ko-KR" altLang="en-US" dirty="0" smtClean="0"/>
+              <a:t>는 </a:t>
+            </a:r>
+            <a:r>
+              <a:rPr lang="en-US" altLang="ko-KR" dirty="0" err="1" smtClean="0"/>
+              <a:t>Webpack</a:t>
+            </a:r>
+            <a:r>
+              <a:rPr lang="en-US" altLang="ko-KR" dirty="0" smtClean="0"/>
+              <a:t>. Babel.</a:t>
+            </a:r>
+            <a:r>
+              <a:rPr lang="en-US" altLang="ko-KR" baseline="0" dirty="0" smtClean="0"/>
+              <a:t> </a:t>
+            </a:r>
+            <a:r>
+              <a:rPr lang="ko-KR" altLang="en-US" baseline="0" dirty="0" smtClean="0"/>
+              <a:t>여러 가지 도구를 포함하고 개발 환경을 구성하고 관리하는 부담을 </a:t>
+            </a:r>
+            <a:r>
+              <a:rPr lang="ko-KR" altLang="en-US" baseline="0" dirty="0" err="1" smtClean="0"/>
+              <a:t>줄여줌</a:t>
+            </a:r>
+            <a:r>
+              <a:rPr lang="en-US" altLang="ko-KR" baseline="0" dirty="0" smtClean="0"/>
+              <a:t>.</a:t>
+            </a:r>
+          </a:p>
+          <a:p>
+            <a:r>
+              <a:rPr lang="ko-KR" altLang="en-US" baseline="0" dirty="0" smtClean="0"/>
+              <a:t>감사해 해야겠죠</a:t>
+            </a:r>
+            <a:r>
+              <a:rPr lang="en-US" altLang="ko-KR" baseline="0" dirty="0" smtClean="0"/>
+              <a:t>?</a:t>
+            </a:r>
             <a:endParaRPr lang="ko-KR" altLang="en-US" dirty="0"/>
           </a:p>
         </p:txBody>
@@ -3587,6 +5324,10 @@
               <a:buFontTx/>
               <a:buNone/>
             </a:pPr>
+            <a:r>
+              <a:rPr lang="en-US" altLang="ko-KR" dirty="0"/>
+              <a:t/>
+            </a:r>
             <a:br>
               <a:rPr lang="en-US" altLang="ko-KR" dirty="0"/>
             </a:br>
@@ -4030,7 +5771,67 @@
             </a:r>
             <a:r>
               <a:rPr lang="en-US" altLang="ko-KR" dirty="0"/>
-              <a:t>– user interface</a:t>
+              <a:t>– user </a:t>
+            </a:r>
+            <a:r>
+              <a:rPr lang="en-US" altLang="ko-KR" dirty="0" smtClean="0"/>
+              <a:t>interface</a:t>
+            </a:r>
+          </a:p>
+          <a:p>
+            <a:endParaRPr lang="en-US" altLang="ko-KR" dirty="0" smtClean="0"/>
+          </a:p>
+          <a:p>
+            <a:r>
+              <a:rPr lang="ko-KR" altLang="en-US" dirty="0" smtClean="0"/>
+              <a:t>왜 쓰냐</a:t>
+            </a:r>
+            <a:r>
+              <a:rPr lang="en-US" altLang="ko-KR" dirty="0" smtClean="0"/>
+              <a:t>?</a:t>
+            </a:r>
+          </a:p>
+          <a:p>
+            <a:r>
+              <a:rPr lang="en-US" altLang="ko-KR" dirty="0" smtClean="0"/>
+              <a:t>Single page application </a:t>
+            </a:r>
+            <a:r>
+              <a:rPr lang="ko-KR" altLang="en-US" dirty="0" smtClean="0"/>
+              <a:t>만들 때 사용</a:t>
+            </a:r>
+            <a:r>
+              <a:rPr lang="en-US" altLang="ko-KR" dirty="0" smtClean="0"/>
+              <a:t>.</a:t>
+            </a:r>
+          </a:p>
+          <a:p>
+            <a:r>
+              <a:rPr lang="ko-KR" altLang="en-US" dirty="0" err="1" smtClean="0"/>
+              <a:t>재사용성이</a:t>
+            </a:r>
+            <a:r>
+              <a:rPr lang="ko-KR" altLang="en-US" dirty="0" smtClean="0"/>
+              <a:t> 용이</a:t>
+            </a:r>
+            <a:endParaRPr lang="en-US" altLang="ko-KR" dirty="0" smtClean="0"/>
+          </a:p>
+          <a:p>
+            <a:r>
+              <a:rPr lang="ko-KR" altLang="en-US" dirty="0" smtClean="0"/>
+              <a:t>같은 앱 개발도 같음 </a:t>
+            </a:r>
+            <a:r>
+              <a:rPr lang="en-US" altLang="ko-KR" dirty="0" smtClean="0"/>
+              <a:t>.</a:t>
+            </a:r>
+            <a:r>
+              <a:rPr lang="en-US" altLang="ko-KR" dirty="0" err="1" smtClean="0"/>
+              <a:t>react.native</a:t>
+            </a:r>
+            <a:r>
+              <a:rPr lang="en-US" altLang="ko-KR" baseline="0" dirty="0" smtClean="0"/>
+              <a:t> </a:t>
             </a:r>
             <a:endParaRPr lang="ko-KR" altLang="en-US" dirty="0"/>
           </a:p>
@@ -4680,7 +6481,7 @@
           <p:nvPr userDrawn="1"/>
         </p:nvPicPr>
         <p:blipFill>
-          <a:blip r:embed="rId2">
+          <a:blip r:embed="rId2" cstate="hqprint">
             <a:alphaModFix amt="20000"/>
             <a:extLst>
               <a:ext uri="{28A0092B-C50C-407E-A947-70E740481C1C}">
@@ -7692,7 +9493,7 @@
           <p:nvPr userDrawn="1"/>
         </p:nvPicPr>
         <p:blipFill>
-          <a:blip r:embed="rId14">
+          <a:blip r:embed="rId14" cstate="hqprint">
             <a:extLst>
               <a:ext uri="{28A0092B-C50C-407E-A947-70E740481C1C}">
                 <a14:useLocalDpi xmlns:a14="http://schemas.microsoft.com/office/drawing/2010/main" val="0"/>
@@ -9247,8 +11048,8 @@
         </p:nvSpPr>
         <p:spPr>
           <a:xfrm>
-            <a:off x="3788701" y="5458280"/>
-            <a:ext cx="7747612" cy="646331"/>
+            <a:off x="3033656" y="5458280"/>
+            <a:ext cx="8502657" cy="646331"/>
           </a:xfrm>
           <a:prstGeom prst="rect">
             <a:avLst/>
@@ -10552,6 +12353,10 @@
               <a:rPr lang="ko-KR" altLang="en-US" dirty="0"/>
               <a:t>는 독립적 </a:t>
             </a:r>
+            <a:r>
+              <a:rPr lang="en-US" altLang="ko-KR" dirty="0"/>
+              <a:t/>
+            </a:r>
             <a:br>
               <a:rPr lang="en-US" altLang="ko-KR" dirty="0"/>
             </a:br>
@@ -11688,7 +13493,7 @@
           <p:nvPr/>
         </p:nvPicPr>
         <p:blipFill>
-          <a:blip r:embed="rId3" cstate="print">
+          <a:blip r:embed="rId3" cstate="hqprint">
             <a:extLst>
               <a:ext uri="{28A0092B-C50C-407E-A947-70E740481C1C}">
                 <a14:useLocalDpi xmlns:a14="http://schemas.microsoft.com/office/drawing/2010/main" val="0"/>
@@ -11905,7 +13710,7 @@
           <p:nvPr/>
         </p:nvPicPr>
         <p:blipFill>
-          <a:blip r:embed="rId3" cstate="print">
+          <a:blip r:embed="rId3" cstate="hqprint">
             <a:extLst>
               <a:ext uri="{28A0092B-C50C-407E-A947-70E740481C1C}">
                 <a14:useLocalDpi xmlns:a14="http://schemas.microsoft.com/office/drawing/2010/main" val="0"/>
@@ -12649,7 +14454,7 @@
         </p:spPr>
         <p:txBody>
           <a:bodyPr>
-            <a:normAutofit/>
+            <a:normAutofit lnSpcReduction="10000"/>
           </a:bodyPr>
           <a:lstStyle/>
           <a:p>

</xml_diff>